<commit_message>
docs(PPT): add dedicated Demand Status Control slide with full lifecycle
New slide: 'Demand Status Control' (21 slides total)
- Intermediate steps: only flow progression, no terminal actions
- Final step: ✅ Approve / 📥 Save to Backlog / ❌ Reject
- Backlog action: one-click, creates pm_requirement, shows 🔄 Reopen
- Reopen: returns to first flow step
- Updated flow step counts: CE 2, OE 3, R&C 4
</commit_message>
<xml_diff>
--- a/Training-PM-Tool.pptx
+++ b/Training-PM-Tool.pptx
@@ -25,6 +25,7 @@
     <p:sldId id="273" r:id="rId24"/>
     <p:sldId id="274" r:id="rId25"/>
     <p:sldId id="275" r:id="rId26"/>
+    <p:sldId id="276" r:id="rId27"/>
   </p:sldIdLst>
   <p:sldSz cx="12191695" cy="6858000" type="screen4x3"/>
   <p:notesSz cx="6858000" cy="9144000"/>
@@ -3271,7 +3272,7 @@
               </a:defRPr>
             </a:pPr>
             <a:r>
-              <a:t>1/20</a:t>
+              <a:t>1/21</a:t>
             </a:r>
           </a:p>
         </p:txBody>
@@ -3601,7 +3602,7 @@
               </a:defRPr>
             </a:pPr>
             <a:r>
-              <a:t>10/20</a:t>
+              <a:t>10/21</a:t>
             </a:r>
           </a:p>
         </p:txBody>
@@ -3928,7 +3929,7 @@
               </a:defRPr>
             </a:pPr>
             <a:r>
-              <a:t>11/20</a:t>
+              <a:t>11/21</a:t>
             </a:r>
           </a:p>
         </p:txBody>
@@ -4250,7 +4251,7 @@
               </a:defRPr>
             </a:pPr>
             <a:r>
-              <a:t>12/20</a:t>
+              <a:t>12/21</a:t>
             </a:r>
           </a:p>
         </p:txBody>
@@ -4576,7 +4577,7 @@
               </a:defRPr>
             </a:pPr>
             <a:r>
-              <a:t>13/20</a:t>
+              <a:t>13/21</a:t>
             </a:r>
           </a:p>
         </p:txBody>
@@ -4841,32 +4842,15 @@
             </a:r>
             <a:br/>
             <a:r>
-              <a:t>• Customer Experience: Submitted → Triaging → Approved (3 steps)</a:t>
-            </a:r>
-            <a:br/>
-            <a:r>
-              <a:t>• Operational Efficiency: Submitted → Triaging → Assessed → Approved (4 steps)</a:t>
-            </a:r>
-            <a:br/>
-            <a:r>
-              <a:t>• Risk &amp; Compliance: Submitted → Triaging → Assessed → PSC Review → Approved (5 steps)</a:t>
-            </a:r>
-            <a:br/>
-            <a:br/>
-            <a:r>
-              <a:t>CHANGING STATUS:</a:t>
-            </a:r>
-            <a:br/>
-            <a:r>
-              <a:t>• Click 'Change Status' button → dropdown shows all next steps from config</a:t>
-            </a:r>
-            <a:br/>
-            <a:r>
-              <a:t>• Selecting 'Approved' opens Convert to Requirement modal</a:t>
-            </a:r>
-            <a:br/>
-            <a:r>
-              <a:t>• Selecting 'Rejected' immediately rejects the demand</a:t>
+              <a:t>• Customer Experience: Submitted → Triaging (2 steps)</a:t>
+            </a:r>
+            <a:br/>
+            <a:r>
+              <a:t>• Operational Efficiency: Submitted → Triaging → Assessed (3 steps)</a:t>
+            </a:r>
+            <a:br/>
+            <a:r>
+              <a:t>• Risk &amp; Compliance: Submitted → Triaging → Assessed → PSC Review (4 steps)</a:t>
             </a:r>
             <a:br/>
             <a:br/>
@@ -4906,7 +4890,7 @@
               </a:defRPr>
             </a:pPr>
             <a:r>
-              <a:t>14/20</a:t>
+              <a:t>14/21</a:t>
             </a:r>
           </a:p>
         </p:txBody>
@@ -5045,7 +5029,7 @@
               </a:defRPr>
             </a:pPr>
             <a:r>
-              <a:t>📋 Sprint Board — Team × Product Grid</a:t>
+              <a:t>📥 Demand Status Control</a:t>
             </a:r>
           </a:p>
         </p:txBody>
@@ -5080,14 +5064,14 @@
               </a:defRPr>
             </a:pPr>
             <a:r>
-              <a:t>Derived from Resource Assignments to Epics</a:t>
+              <a:t>Flow Steps at Intermediate · Terminal Actions at Final</a:t>
             </a:r>
           </a:p>
         </p:txBody>
       </p:sp>
       <p:pic>
         <p:nvPicPr>
-          <p:cNvPr id="5" name="Picture 4" descr="sprints.png"/>
+          <p:cNvPr id="5" name="Picture 4" descr="demand.png"/>
           <p:cNvPicPr>
             <a:picLocks noChangeAspect="1"/>
           </p:cNvPicPr>
@@ -5142,66 +5126,68 @@
               </a:defRPr>
             </a:pPr>
             <a:r>
-              <a:t>HOW IT WORKS:</a:t>
-            </a:r>
-            <a:br/>
-            <a:r>
-              <a:t>• Teams (rows) are derived from resource assignments → epics</a:t>
-            </a:r>
-            <a:br/>
-            <a:r>
-              <a:t>• Products (columns) are derived from release items → stories → epics → projects → products</a:t>
-            </a:r>
-            <a:br/>
-            <a:r>
-              <a:t>• Each cell shows sprint cards for that Team × Product combination</a:t>
-            </a:r>
-            <a:br/>
-            <a:br/>
-            <a:r>
-              <a:t>SPRINT CARD SHOWS:</a:t>
-            </a:r>
-            <a:br/>
-            <a:r>
-              <a:t>• Sprint name &amp; status badge</a:t>
-            </a:r>
-            <a:br/>
-            <a:r>
-              <a:t>• Release &amp; cutoff dates</a:t>
-            </a:r>
-            <a:br/>
-            <a:r>
-              <a:t>• Story count &amp; signoff progress</a:t>
-            </a:r>
-            <a:br/>
-            <a:r>
-              <a:t>• Story Points: completed / total (e.g. 21/26 SP)</a:t>
-            </a:r>
-            <a:br/>
-            <a:r>
-              <a:t>• Progress bar for pending signoffs</a:t>
-            </a:r>
-            <a:br/>
-            <a:br/>
-            <a:r>
-              <a:t>FILTERS:</a:t>
-            </a:r>
-            <a:br/>
-            <a:r>
-              <a:t>• ☑ Show completed sprints — toggle to see Released sprints</a:t>
-            </a:r>
-            <a:br/>
-            <a:r>
-              <a:t>• Role-based: VSO sees only their VS products</a:t>
-            </a:r>
-            <a:br/>
-            <a:r>
-              <a:t>• BA sees only products with active demands</a:t>
-            </a:r>
-            <a:br/>
-            <a:br/>
-            <a:r>
-              <a:t>Click any card → navigates to Releases tab with auto-expand</a:t>
+              <a:t>INTERMEDIATE STEPS (has next flow step):</a:t>
+            </a:r>
+            <a:br/>
+            <a:r>
+              <a:t>• Popup shows ONLY flow progression options</a:t>
+            </a:r>
+            <a:br/>
+            <a:r>
+              <a:t>• e.g., 'Submitted' shows 'Triaging'</a:t>
+            </a:r>
+            <a:br/>
+            <a:r>
+              <a:t>• Prevents accidental early termination</a:t>
+            </a:r>
+            <a:br/>
+            <a:br/>
+            <a:r>
+              <a:t>FINAL FLOW STEP (no more progression):</a:t>
+            </a:r>
+            <a:br/>
+            <a:r>
+              <a:t>• Popup shows ONLY terminal actions:</a:t>
+            </a:r>
+            <a:br/>
+            <a:br/>
+            <a:r>
+              <a:t>  ✅ Approve — opens Convert Modal</a:t>
+            </a:r>
+            <a:br/>
+            <a:r>
+              <a:t>     → Can create Requirement (linked) or Backlog (unlinked)</a:t>
+            </a:r>
+            <a:br/>
+            <a:br/>
+            <a:r>
+              <a:t>  📥 Save to Backlog — one-click creates backlog item</a:t>
+            </a:r>
+            <a:br/>
+            <a:r>
+              <a:t>     → Demand hidden from active list</a:t>
+            </a:r>
+            <a:br/>
+            <a:r>
+              <a:t>     → Backlogged demands show 🔄 Reopen button</a:t>
+            </a:r>
+            <a:br/>
+            <a:br/>
+            <a:r>
+              <a:t>  ❌ Reject — hides demand permanently</a:t>
+            </a:r>
+            <a:br/>
+            <a:br/>
+            <a:r>
+              <a:t>REOPEN (Backlogged demands):</a:t>
+            </a:r>
+            <a:br/>
+            <a:r>
+              <a:t>• 🔄 Reopen returns demand to first flow step</a:t>
+            </a:r>
+            <a:br/>
+            <a:r>
+              <a:t>• Demand reappears in active list — can re-enter workflow</a:t>
             </a:r>
           </a:p>
         </p:txBody>
@@ -5236,7 +5222,7 @@
               </a:defRPr>
             </a:pPr>
             <a:r>
-              <a:t>15/20</a:t>
+              <a:t>15/21</a:t>
             </a:r>
           </a:p>
         </p:txBody>
@@ -5375,7 +5361,7 @@
               </a:defRPr>
             </a:pPr>
             <a:r>
-              <a:t>✅ Governance Checklist</a:t>
+              <a:t>📋 Sprint Board — Team × Product Grid</a:t>
             </a:r>
           </a:p>
         </p:txBody>
@@ -5410,14 +5396,14 @@
               </a:defRPr>
             </a:pPr>
             <a:r>
-              <a:t>Per-project, per-phase, fully configurable</a:t>
+              <a:t>Derived from Resource Assignments to Epics</a:t>
             </a:r>
           </a:p>
         </p:txBody>
       </p:sp>
       <p:pic>
         <p:nvPicPr>
-          <p:cNvPr id="5" name="Picture 4" descr="governance.png"/>
+          <p:cNvPr id="5" name="Picture 4" descr="sprints.png"/>
           <p:cNvPicPr>
             <a:picLocks noChangeAspect="1"/>
           </p:cNvPicPr>
@@ -5476,62 +5462,62 @@
             </a:r>
             <a:br/>
             <a:r>
-              <a:t>• Each project has a governance template (auto-detect or explicit)</a:t>
-            </a:r>
-            <a:br/>
-            <a:r>
-              <a:t>• Template determines which phases and checklist items appear</a:t>
-            </a:r>
-            <a:br/>
-            <a:r>
-              <a:t>• Phases are configurable per value stream</a:t>
-            </a:r>
-            <a:br/>
-            <a:r>
-              <a:t>• Checklist items are configurable per VS + phase</a:t>
-            </a:r>
-            <a:br/>
-            <a:br/>
-            <a:r>
-              <a:t>PER-PROJECT TEMPLATE ASSIGNMENT:</a:t>
-            </a:r>
-            <a:br/>
-            <a:r>
-              <a:t>• Edit a project → Gov Template dropdown</a:t>
-            </a:r>
-            <a:br/>
-            <a:r>
-              <a:t>• 'Auto-detect from VS' — uses product's value stream</a:t>
-            </a:r>
-            <a:br/>
-            <a:r>
-              <a:t>• Explicit template — locks to a specific VS template</a:t>
-            </a:r>
-            <a:br/>
-            <a:br/>
-            <a:r>
-              <a:t>EDITING ITEMS:</a:t>
-            </a:r>
-            <a:br/>
-            <a:r>
-              <a:t>• Status dropdown: To Do / In Progress / Done / N/A</a:t>
-            </a:r>
-            <a:br/>
-            <a:r>
-              <a:t>• Owner input, Plan Start/End, Actual Start/End — all inline editable</a:t>
-            </a:r>
-            <a:br/>
-            <a:r>
-              <a:t>• Config-only items auto-create on first edit</a:t>
-            </a:r>
-            <a:br/>
-            <a:r>
-              <a:t>• 'Generate N Items' button creates all missing items at once</a:t>
-            </a:r>
-            <a:br/>
-            <a:br/>
-            <a:r>
-              <a:t>FILTERS: Project dropdown + Phase dropdown + Search bar</a:t>
+              <a:t>• Teams (rows) are derived from resource assignments → epics</a:t>
+            </a:r>
+            <a:br/>
+            <a:r>
+              <a:t>• Products (columns) are derived from release items → stories → epics → projects → products</a:t>
+            </a:r>
+            <a:br/>
+            <a:r>
+              <a:t>• Each cell shows sprint cards for that Team × Product combination</a:t>
+            </a:r>
+            <a:br/>
+            <a:br/>
+            <a:r>
+              <a:t>SPRINT CARD SHOWS:</a:t>
+            </a:r>
+            <a:br/>
+            <a:r>
+              <a:t>• Sprint name &amp; status badge</a:t>
+            </a:r>
+            <a:br/>
+            <a:r>
+              <a:t>• Release &amp; cutoff dates</a:t>
+            </a:r>
+            <a:br/>
+            <a:r>
+              <a:t>• Story count &amp; signoff progress</a:t>
+            </a:r>
+            <a:br/>
+            <a:r>
+              <a:t>• Story Points: completed / total (e.g. 21/26 SP)</a:t>
+            </a:r>
+            <a:br/>
+            <a:r>
+              <a:t>• Progress bar for pending signoffs</a:t>
+            </a:r>
+            <a:br/>
+            <a:br/>
+            <a:r>
+              <a:t>FILTERS:</a:t>
+            </a:r>
+            <a:br/>
+            <a:r>
+              <a:t>• ☑ Show completed sprints — toggle to see Released sprints</a:t>
+            </a:r>
+            <a:br/>
+            <a:r>
+              <a:t>• Role-based: VSO sees only their VS products</a:t>
+            </a:r>
+            <a:br/>
+            <a:r>
+              <a:t>• BA sees only products with active demands</a:t>
+            </a:r>
+            <a:br/>
+            <a:br/>
+            <a:r>
+              <a:t>Click any card → navigates to Releases tab with auto-expand</a:t>
             </a:r>
           </a:p>
         </p:txBody>
@@ -5566,7 +5552,7 @@
               </a:defRPr>
             </a:pPr>
             <a:r>
-              <a:t>16/20</a:t>
+              <a:t>16/21</a:t>
             </a:r>
           </a:p>
         </p:txBody>
@@ -5705,7 +5691,7 @@
               </a:defRPr>
             </a:pPr>
             <a:r>
-              <a:t>🚀 Release Management</a:t>
+              <a:t>✅ Governance Checklist</a:t>
             </a:r>
           </a:p>
         </p:txBody>
@@ -5740,14 +5726,14 @@
               </a:defRPr>
             </a:pPr>
             <a:r>
-              <a:t>Epic-grouped with signoff workflow</a:t>
+              <a:t>Per-project, per-phase, fully configurable</a:t>
             </a:r>
           </a:p>
         </p:txBody>
       </p:sp>
       <p:pic>
         <p:nvPicPr>
-          <p:cNvPr id="5" name="Picture 4" descr="releases.png"/>
+          <p:cNvPr id="5" name="Picture 4" descr="governance.png"/>
           <p:cNvPicPr>
             <a:picLocks noChangeAspect="1"/>
           </p:cNvPicPr>
@@ -5802,58 +5788,66 @@
               </a:defRPr>
             </a:pPr>
             <a:r>
-              <a:t>RELEASE LIFECYCLE:</a:t>
-            </a:r>
-            <a:br/>
-            <a:r>
-              <a:t>• Draft → Open → In Review → Released</a:t>
-            </a:r>
-            <a:br/>
-            <a:r>
-              <a:t>• Workflow buttons appear based on current status</a:t>
-            </a:r>
-            <a:br/>
-            <a:br/>
-            <a:r>
-              <a:t>REGISTERING STORIES:</a:t>
-            </a:r>
-            <a:br/>
-            <a:r>
-              <a:t>• Click ➕ Register on an Open release</a:t>
-            </a:r>
-            <a:br/>
-            <a:r>
-              <a:t>• Select unregistered user stories</a:t>
-            </a:r>
-            <a:br/>
-            <a:r>
-              <a:t>• Stories grouped by Epic (two-level expand)</a:t>
-            </a:r>
-            <a:br/>
-            <a:br/>
-            <a:r>
-              <a:t>SIGNOFF WORKFLOW:</a:t>
-            </a:r>
-            <a:br/>
-            <a:r>
-              <a:t>• Individual story signoff: Pending → Approved / Rejected</a:t>
-            </a:r>
-            <a:br/>
-            <a:r>
-              <a:t>• ✍️ Signoff button appears on each pending story</a:t>
-            </a:r>
-            <a:br/>
-            <a:r>
-              <a:t>• Signoff modal: Decision (Approved/Rejected) + Note</a:t>
-            </a:r>
-            <a:br/>
-            <a:r>
-              <a:t>• Signoff recorded with by/date metadata</a:t>
-            </a:r>
-            <a:br/>
-            <a:br/>
-            <a:r>
-              <a:t>Click any release row → expands epics → expands stories</a:t>
+              <a:t>HOW IT WORKS:</a:t>
+            </a:r>
+            <a:br/>
+            <a:r>
+              <a:t>• Each project has a governance template (auto-detect or explicit)</a:t>
+            </a:r>
+            <a:br/>
+            <a:r>
+              <a:t>• Template determines which phases and checklist items appear</a:t>
+            </a:r>
+            <a:br/>
+            <a:r>
+              <a:t>• Phases are configurable per value stream</a:t>
+            </a:r>
+            <a:br/>
+            <a:r>
+              <a:t>• Checklist items are configurable per VS + phase</a:t>
+            </a:r>
+            <a:br/>
+            <a:br/>
+            <a:r>
+              <a:t>PER-PROJECT TEMPLATE ASSIGNMENT:</a:t>
+            </a:r>
+            <a:br/>
+            <a:r>
+              <a:t>• Edit a project → Gov Template dropdown</a:t>
+            </a:r>
+            <a:br/>
+            <a:r>
+              <a:t>• 'Auto-detect from VS' — uses product's value stream</a:t>
+            </a:r>
+            <a:br/>
+            <a:r>
+              <a:t>• Explicit template — locks to a specific VS template</a:t>
+            </a:r>
+            <a:br/>
+            <a:br/>
+            <a:r>
+              <a:t>EDITING ITEMS:</a:t>
+            </a:r>
+            <a:br/>
+            <a:r>
+              <a:t>• Status dropdown: To Do / In Progress / Done / N/A</a:t>
+            </a:r>
+            <a:br/>
+            <a:r>
+              <a:t>• Owner input, Plan Start/End, Actual Start/End — all inline editable</a:t>
+            </a:r>
+            <a:br/>
+            <a:r>
+              <a:t>• Config-only items auto-create on first edit</a:t>
+            </a:r>
+            <a:br/>
+            <a:r>
+              <a:t>• 'Generate N Items' button creates all missing items at once</a:t>
+            </a:r>
+            <a:br/>
+            <a:br/>
+            <a:r>
+              <a:t>FILTERS: Project dropdown + Phase dropdown + Search bar</a:t>
             </a:r>
           </a:p>
         </p:txBody>
@@ -5888,7 +5882,7 @@
               </a:defRPr>
             </a:pPr>
             <a:r>
-              <a:t>17/20</a:t>
+              <a:t>17/21</a:t>
             </a:r>
           </a:p>
         </p:txBody>
@@ -6027,7 +6021,7 @@
               </a:defRPr>
             </a:pPr>
             <a:r>
-              <a:t>📈 Portfolio View</a:t>
+              <a:t>🚀 Release Management</a:t>
             </a:r>
           </a:p>
         </p:txBody>
@@ -6062,14 +6056,14 @@
               </a:defRPr>
             </a:pPr>
             <a:r>
-              <a:t>Value Stream grouped product cards with holistic metrics</a:t>
+              <a:t>Epic-grouped with signoff workflow</a:t>
             </a:r>
           </a:p>
         </p:txBody>
       </p:sp>
       <p:pic>
         <p:nvPicPr>
-          <p:cNvPr id="5" name="Picture 4" descr="portfolio.png"/>
+          <p:cNvPr id="5" name="Picture 4" descr="releases.png"/>
           <p:cNvPicPr>
             <a:picLocks noChangeAspect="1"/>
           </p:cNvPicPr>
@@ -6124,62 +6118,58 @@
               </a:defRPr>
             </a:pPr>
             <a:r>
-              <a:t>PER-PRODUCT CARD SHOWS:</a:t>
-            </a:r>
-            <a:br/>
-            <a:r>
-              <a:t>• Demand count with status breakdown badges</a:t>
-            </a:r>
-            <a:br/>
-            <a:r>
-              <a:t>• Project count</a:t>
-            </a:r>
-            <a:br/>
-            <a:r>
-              <a:t>• Story Points: done/total with progress bar</a:t>
-            </a:r>
-            <a:br/>
-            <a:r>
-              <a:t>• Teams involved (from assignment chain)</a:t>
-            </a:r>
-            <a:br/>
-            <a:r>
-              <a:t>• Active sprints count</a:t>
-            </a:r>
-            <a:br/>
-            <a:r>
-              <a:t>• Risk &amp; dependency counts</a:t>
-            </a:r>
-            <a:br/>
-            <a:br/>
-            <a:r>
-              <a:t>VALUE STREAM HEADER:</a:t>
-            </a:r>
-            <a:br/>
-            <a:r>
-              <a:t>• Flow step count badge (e.g. '4 steps')</a:t>
-            </a:r>
-            <a:br/>
-            <a:r>
-              <a:t>• Product count</a:t>
-            </a:r>
-            <a:br/>
-            <a:br/>
-            <a:r>
-              <a:t>ROLE FILTERING:</a:t>
-            </a:r>
-            <a:br/>
-            <a:r>
-              <a:t>• VSO: only their assigned value stream products</a:t>
-            </a:r>
-            <a:br/>
-            <a:r>
-              <a:t>• All others: full view</a:t>
-            </a:r>
-            <a:br/>
-            <a:br/>
-            <a:r>
-              <a:t>Click any card → navigates to Products tab</a:t>
+              <a:t>RELEASE LIFECYCLE:</a:t>
+            </a:r>
+            <a:br/>
+            <a:r>
+              <a:t>• Draft → Open → In Review → Released</a:t>
+            </a:r>
+            <a:br/>
+            <a:r>
+              <a:t>• Workflow buttons appear based on current status</a:t>
+            </a:r>
+            <a:br/>
+            <a:br/>
+            <a:r>
+              <a:t>REGISTERING STORIES:</a:t>
+            </a:r>
+            <a:br/>
+            <a:r>
+              <a:t>• Click ➕ Register on an Open release</a:t>
+            </a:r>
+            <a:br/>
+            <a:r>
+              <a:t>• Select unregistered user stories</a:t>
+            </a:r>
+            <a:br/>
+            <a:r>
+              <a:t>• Stories grouped by Epic (two-level expand)</a:t>
+            </a:r>
+            <a:br/>
+            <a:br/>
+            <a:r>
+              <a:t>SIGNOFF WORKFLOW:</a:t>
+            </a:r>
+            <a:br/>
+            <a:r>
+              <a:t>• Individual story signoff: Pending → Approved / Rejected</a:t>
+            </a:r>
+            <a:br/>
+            <a:r>
+              <a:t>• ✍️ Signoff button appears on each pending story</a:t>
+            </a:r>
+            <a:br/>
+            <a:r>
+              <a:t>• Signoff modal: Decision (Approved/Rejected) + Note</a:t>
+            </a:r>
+            <a:br/>
+            <a:r>
+              <a:t>• Signoff recorded with by/date metadata</a:t>
+            </a:r>
+            <a:br/>
+            <a:br/>
+            <a:r>
+              <a:t>Click any release row → expands epics → expands stories</a:t>
             </a:r>
           </a:p>
         </p:txBody>
@@ -6214,7 +6204,7 @@
               </a:defRPr>
             </a:pPr>
             <a:r>
-              <a:t>18/20</a:t>
+              <a:t>18/21</a:t>
             </a:r>
           </a:p>
         </p:txBody>
@@ -6353,7 +6343,7 @@
               </a:defRPr>
             </a:pPr>
             <a:r>
-              <a:t>Getting Started — Quick Reference</a:t>
+              <a:t>📈 Portfolio View</a:t>
             </a:r>
           </a:p>
         </p:txBody>
@@ -6366,8 +6356,67 @@
         </p:nvSpPr>
         <p:spPr>
           <a:xfrm>
-            <a:off x="731520" y="1371600"/>
-            <a:ext cx="10698480" cy="4846320"/>
+            <a:off x="731520" y="658368"/>
+            <a:ext cx="10515600" cy="320040"/>
+          </a:xfrm>
+          <a:prstGeom prst="rect">
+            <a:avLst/>
+          </a:prstGeom>
+          <a:noFill/>
+        </p:spPr>
+        <p:txBody>
+          <a:bodyPr wrap="none">
+            <a:spAutoFit/>
+          </a:bodyPr>
+          <a:lstStyle/>
+          <a:p>
+            <a:pPr algn="l">
+              <a:defRPr sz="1400">
+                <a:solidFill>
+                  <a:srgbClr val="C7D2FE"/>
+                </a:solidFill>
+              </a:defRPr>
+            </a:pPr>
+            <a:r>
+              <a:t>Value Stream grouped product cards with holistic metrics</a:t>
+            </a:r>
+          </a:p>
+        </p:txBody>
+      </p:sp>
+      <p:pic>
+        <p:nvPicPr>
+          <p:cNvPr id="5" name="Picture 4" descr="portfolio.png"/>
+          <p:cNvPicPr>
+            <a:picLocks noChangeAspect="1"/>
+          </p:cNvPicPr>
+          <p:nvPr/>
+        </p:nvPicPr>
+        <p:blipFill>
+          <a:blip r:embed="rId2"/>
+          <a:stretch>
+            <a:fillRect/>
+          </a:stretch>
+        </p:blipFill>
+        <p:spPr>
+          <a:xfrm>
+            <a:off x="457200" y="1371600"/>
+            <a:ext cx="6858000" cy="5029200"/>
+          </a:xfrm>
+          <a:prstGeom prst="rect">
+            <a:avLst/>
+          </a:prstGeom>
+        </p:spPr>
+      </p:pic>
+      <p:sp>
+        <p:nvSpPr>
+          <p:cNvPr id="6" name="TextBox 5"/>
+          <p:cNvSpPr txBox="1"/>
+          <p:nvPr/>
+        </p:nvSpPr>
+        <p:spPr>
+          <a:xfrm>
+            <a:off x="7589520" y="1371600"/>
+            <a:ext cx="4297680" cy="5029200"/>
           </a:xfrm>
           <a:prstGeom prst="rect">
             <a:avLst/>
@@ -6382,91 +6431,78 @@
           <a:p>
             <a:pPr>
               <a:lnSpc>
-                <a:spcPts val="1900"/>
+                <a:spcPts val="1800"/>
               </a:lnSpc>
-              <a:defRPr sz="1300">
+              <a:defRPr sz="1200">
                 <a:solidFill>
                   <a:srgbClr val="0F172A"/>
                 </a:solidFill>
               </a:defRPr>
             </a:pPr>
             <a:r>
-              <a:t>1️⃣ RAISE A DEMAND: Go to 📥 Demand → + Raise Demand</a:t>
-            </a:r>
-            <a:br/>
-            <a:br/>
-            <a:r>
-              <a:t>2️⃣ WORKFLOW: Click Change Status on a demand to advance it</a:t>
-            </a:r>
-            <a:br/>
-            <a:r>
-              <a:t>  → Last step (Approved) creates a Requirement</a:t>
-            </a:r>
-            <a:br/>
-            <a:br/>
-            <a:r>
-              <a:t>3️⃣ CREATE A PROJECT: Go to 📁 Projects → + New Project</a:t>
-            </a:r>
-            <a:br/>
-            <a:r>
-              <a:t>  → Assign a Governance Template if needed</a:t>
-            </a:r>
-            <a:br/>
-            <a:br/>
-            <a:r>
-              <a:t>4️⃣ MANAGE EPICS &amp; STORIES: Break down requirements</a:t>
-            </a:r>
-            <a:br/>
-            <a:r>
-              <a:t>  → Assign resources to epics (determines Sprint Board teams)</a:t>
-            </a:r>
-            <a:br/>
-            <a:br/>
-            <a:r>
-              <a:t>5️⃣ GOVERNANCE CHECKLIST: Go to ✅ Governance</a:t>
-            </a:r>
-            <a:br/>
-            <a:r>
-              <a:t>  → Click Generate Items or edit items individually</a:t>
-            </a:r>
-            <a:br/>
-            <a:br/>
-            <a:r>
-              <a:t>6️⃣ CREATE A RELEASE: Go to 🚀 Releases → + New Release</a:t>
-            </a:r>
-            <a:br/>
-            <a:r>
-              <a:t>  → Register stories, sign off when ready</a:t>
-            </a:r>
-            <a:br/>
-            <a:br/>
-            <a:r>
-              <a:t>7️⃣ VIEW SPRINTS: Go to 📋 Sprints for Team×Product grid</a:t>
-            </a:r>
-            <a:br/>
-            <a:r>
-              <a:t>  → Toggle 'Show completed' as needed</a:t>
-            </a:r>
-            <a:br/>
-            <a:br/>
-            <a:r>
-              <a:t>8️⃣ CHECK PORTFOLIO: Go to 📈 Portfolio for holistic view</a:t>
-            </a:r>
-            <a:br/>
-            <a:br/>
-            <a:r>
-              <a:t>🔄 RESET DATA: Click 🔄 Reset in the header to clear all data</a:t>
-            </a:r>
-            <a:br/>
-            <a:r>
-              <a:t>👤 SWITCH ROLE: Use the role dropdown in the header</a:t>
-            </a:r>
-          </a:p>
-        </p:txBody>
-      </p:sp>
-      <p:sp>
-        <p:nvSpPr>
-          <p:cNvPr id="5" name="TextBox 4"/>
+              <a:t>PER-PRODUCT CARD SHOWS:</a:t>
+            </a:r>
+            <a:br/>
+            <a:r>
+              <a:t>• Demand count with status breakdown badges</a:t>
+            </a:r>
+            <a:br/>
+            <a:r>
+              <a:t>• Project count</a:t>
+            </a:r>
+            <a:br/>
+            <a:r>
+              <a:t>• Story Points: done/total with progress bar</a:t>
+            </a:r>
+            <a:br/>
+            <a:r>
+              <a:t>• Teams involved (from assignment chain)</a:t>
+            </a:r>
+            <a:br/>
+            <a:r>
+              <a:t>• Active sprints count</a:t>
+            </a:r>
+            <a:br/>
+            <a:r>
+              <a:t>• Risk &amp; dependency counts</a:t>
+            </a:r>
+            <a:br/>
+            <a:br/>
+            <a:r>
+              <a:t>VALUE STREAM HEADER:</a:t>
+            </a:r>
+            <a:br/>
+            <a:r>
+              <a:t>• Flow step count badge (e.g. '4 steps')</a:t>
+            </a:r>
+            <a:br/>
+            <a:r>
+              <a:t>• Product count</a:t>
+            </a:r>
+            <a:br/>
+            <a:br/>
+            <a:r>
+              <a:t>ROLE FILTERING:</a:t>
+            </a:r>
+            <a:br/>
+            <a:r>
+              <a:t>• VSO: only their assigned value stream products</a:t>
+            </a:r>
+            <a:br/>
+            <a:r>
+              <a:t>• All others: full view</a:t>
+            </a:r>
+            <a:br/>
+            <a:br/>
+            <a:r>
+              <a:t>Click any card → navigates to Products tab</a:t>
+            </a:r>
+          </a:p>
+        </p:txBody>
+      </p:sp>
+      <p:sp>
+        <p:nvSpPr>
+          <p:cNvPr id="7" name="TextBox 6"/>
           <p:cNvSpPr txBox="1"/>
           <p:nvPr/>
         </p:nvSpPr>
@@ -6494,14 +6530,14 @@
               </a:defRPr>
             </a:pPr>
             <a:r>
-              <a:t>19/20</a:t>
-            </a:r>
-          </a:p>
-        </p:txBody>
-      </p:sp>
-      <p:sp>
-        <p:nvSpPr>
-          <p:cNvPr id="6" name="TextBox 5"/>
+              <a:t>19/21</a:t>
+            </a:r>
+          </a:p>
+        </p:txBody>
+      </p:sp>
+      <p:sp>
+        <p:nvSpPr>
+          <p:cNvPr id="8" name="TextBox 7"/>
           <p:cNvSpPr txBox="1"/>
           <p:nvPr/>
         </p:nvSpPr>
@@ -6759,7 +6795,7 @@
               </a:defRPr>
             </a:pPr>
             <a:r>
-              <a:t>2/20</a:t>
+              <a:t>2/21</a:t>
             </a:r>
           </a:p>
         </p:txBody>
@@ -6898,6 +6934,286 @@
               </a:defRPr>
             </a:pPr>
             <a:r>
+              <a:t>Getting Started — Quick Reference</a:t>
+            </a:r>
+          </a:p>
+        </p:txBody>
+      </p:sp>
+      <p:sp>
+        <p:nvSpPr>
+          <p:cNvPr id="4" name="TextBox 3"/>
+          <p:cNvSpPr txBox="1"/>
+          <p:nvPr/>
+        </p:nvSpPr>
+        <p:spPr>
+          <a:xfrm>
+            <a:off x="731520" y="1371600"/>
+            <a:ext cx="10698480" cy="4846320"/>
+          </a:xfrm>
+          <a:prstGeom prst="rect">
+            <a:avLst/>
+          </a:prstGeom>
+          <a:noFill/>
+        </p:spPr>
+        <p:txBody>
+          <a:bodyPr wrap="square">
+            <a:spAutoFit/>
+          </a:bodyPr>
+          <a:lstStyle/>
+          <a:p>
+            <a:pPr>
+              <a:lnSpc>
+                <a:spcPts val="1900"/>
+              </a:lnSpc>
+              <a:defRPr sz="1300">
+                <a:solidFill>
+                  <a:srgbClr val="0F172A"/>
+                </a:solidFill>
+              </a:defRPr>
+            </a:pPr>
+            <a:r>
+              <a:t>1️⃣ RAISE A DEMAND: Go to 📥 Demand → + Raise Demand</a:t>
+            </a:r>
+            <a:br/>
+            <a:br/>
+            <a:r>
+              <a:t>2️⃣ WORKFLOW: Click Change Status on a demand to advance it</a:t>
+            </a:r>
+            <a:br/>
+            <a:r>
+              <a:t>  → Last step (Approved) creates a Requirement</a:t>
+            </a:r>
+            <a:br/>
+            <a:br/>
+            <a:r>
+              <a:t>3️⃣ CREATE A PROJECT: Go to 📁 Projects → + New Project</a:t>
+            </a:r>
+            <a:br/>
+            <a:r>
+              <a:t>  → Assign a Governance Template if needed</a:t>
+            </a:r>
+            <a:br/>
+            <a:br/>
+            <a:r>
+              <a:t>4️⃣ MANAGE EPICS &amp; STORIES: Break down requirements</a:t>
+            </a:r>
+            <a:br/>
+            <a:r>
+              <a:t>  → Assign resources to epics (determines Sprint Board teams)</a:t>
+            </a:r>
+            <a:br/>
+            <a:br/>
+            <a:r>
+              <a:t>5️⃣ GOVERNANCE CHECKLIST: Go to ✅ Governance</a:t>
+            </a:r>
+            <a:br/>
+            <a:r>
+              <a:t>  → Click Generate Items or edit items individually</a:t>
+            </a:r>
+            <a:br/>
+            <a:br/>
+            <a:r>
+              <a:t>6️⃣ CREATE A RELEASE: Go to 🚀 Releases → + New Release</a:t>
+            </a:r>
+            <a:br/>
+            <a:r>
+              <a:t>  → Register stories, sign off when ready</a:t>
+            </a:r>
+            <a:br/>
+            <a:br/>
+            <a:r>
+              <a:t>7️⃣ VIEW SPRINTS: Go to 📋 Sprints for Team×Product grid</a:t>
+            </a:r>
+            <a:br/>
+            <a:r>
+              <a:t>  → Toggle 'Show completed' as needed</a:t>
+            </a:r>
+            <a:br/>
+            <a:br/>
+            <a:r>
+              <a:t>8️⃣ CHECK PORTFOLIO: Go to 📈 Portfolio for holistic view</a:t>
+            </a:r>
+            <a:br/>
+            <a:br/>
+            <a:r>
+              <a:t>🔄 RESET DATA: Click 🔄 Reset in the header to clear all data</a:t>
+            </a:r>
+            <a:br/>
+            <a:r>
+              <a:t>👤 SWITCH ROLE: Use the role dropdown in the header</a:t>
+            </a:r>
+          </a:p>
+        </p:txBody>
+      </p:sp>
+      <p:sp>
+        <p:nvSpPr>
+          <p:cNvPr id="5" name="TextBox 4"/>
+          <p:cNvSpPr txBox="1"/>
+          <p:nvPr/>
+        </p:nvSpPr>
+        <p:spPr>
+          <a:xfrm>
+            <a:off x="11155680" y="777240"/>
+            <a:ext cx="731520" cy="274320"/>
+          </a:xfrm>
+          <a:prstGeom prst="rect">
+            <a:avLst/>
+          </a:prstGeom>
+          <a:noFill/>
+        </p:spPr>
+        <p:txBody>
+          <a:bodyPr wrap="none">
+            <a:spAutoFit/>
+          </a:bodyPr>
+          <a:lstStyle/>
+          <a:p>
+            <a:pPr algn="r">
+              <a:defRPr sz="1000">
+                <a:solidFill>
+                  <a:srgbClr val="C7D2FE"/>
+                </a:solidFill>
+              </a:defRPr>
+            </a:pPr>
+            <a:r>
+              <a:t>20/21</a:t>
+            </a:r>
+          </a:p>
+        </p:txBody>
+      </p:sp>
+      <p:sp>
+        <p:nvSpPr>
+          <p:cNvPr id="6" name="TextBox 5"/>
+          <p:cNvSpPr txBox="1"/>
+          <p:nvPr/>
+        </p:nvSpPr>
+        <p:spPr>
+          <a:xfrm>
+            <a:off x="457200" y="6446520"/>
+            <a:ext cx="11247120" cy="274320"/>
+          </a:xfrm>
+          <a:prstGeom prst="rect">
+            <a:avLst/>
+          </a:prstGeom>
+          <a:noFill/>
+        </p:spPr>
+        <p:txBody>
+          <a:bodyPr wrap="none">
+            <a:spAutoFit/>
+          </a:bodyPr>
+          <a:lstStyle/>
+          <a:p>
+            <a:pPr algn="ctr">
+              <a:defRPr sz="800">
+                <a:solidFill>
+                  <a:srgbClr val="64748B"/>
+                </a:solidFill>
+              </a:defRPr>
+            </a:pPr>
+            <a:r>
+              <a:t>Project Management Tool — Training Guide</a:t>
+            </a:r>
+          </a:p>
+        </p:txBody>
+      </p:sp>
+    </p:spTree>
+  </p:cSld>
+  <p:clrMapOvr>
+    <a:masterClrMapping/>
+  </p:clrMapOvr>
+</p:sld>
+</file>
+
+<file path=ppt/slides/slide21.xml><?xml version="1.0" encoding="utf-8"?>
+<p:sld xmlns:a="http://schemas.openxmlformats.org/drawingml/2006/main" xmlns:p="http://schemas.openxmlformats.org/presentationml/2006/main" xmlns:r="http://schemas.openxmlformats.org/officeDocument/2006/relationships">
+  <p:cSld>
+    <p:bg>
+      <p:bgPr>
+        <a:solidFill>
+          <a:srgbClr val="FFFFFF"/>
+        </a:solidFill>
+        <a:effectLst/>
+      </p:bgPr>
+    </p:bg>
+    <p:spTree>
+      <p:nvGrpSpPr>
+        <p:cNvPr id="1" name=""/>
+        <p:cNvGrpSpPr/>
+        <p:nvPr/>
+      </p:nvGrpSpPr>
+      <p:grpSpPr/>
+      <p:sp>
+        <p:nvSpPr>
+          <p:cNvPr id="2" name="Rectangle 1"/>
+          <p:cNvSpPr/>
+          <p:nvPr/>
+        </p:nvSpPr>
+        <p:spPr>
+          <a:xfrm>
+            <a:off x="0" y="0"/>
+            <a:ext cx="12191695" cy="1097280"/>
+          </a:xfrm>
+          <a:prstGeom prst="rect">
+            <a:avLst/>
+          </a:prstGeom>
+          <a:solidFill>
+            <a:srgbClr val="6366F1"/>
+          </a:solidFill>
+          <a:ln>
+            <a:noFill/>
+          </a:ln>
+        </p:spPr>
+        <p:style>
+          <a:lnRef idx="1">
+            <a:schemeClr val="accent1"/>
+          </a:lnRef>
+          <a:fillRef idx="3">
+            <a:schemeClr val="accent1"/>
+          </a:fillRef>
+          <a:effectRef idx="2">
+            <a:schemeClr val="accent1"/>
+          </a:effectRef>
+          <a:fontRef idx="minor">
+            <a:schemeClr val="lt1"/>
+          </a:fontRef>
+        </p:style>
+        <p:txBody>
+          <a:bodyPr rtlCol="0" anchor="ctr"/>
+          <a:lstStyle/>
+          <a:p>
+            <a:pPr algn="ctr"/>
+          </a:p>
+        </p:txBody>
+      </p:sp>
+      <p:sp>
+        <p:nvSpPr>
+          <p:cNvPr id="3" name="TextBox 2"/>
+          <p:cNvSpPr txBox="1"/>
+          <p:nvPr/>
+        </p:nvSpPr>
+        <p:spPr>
+          <a:xfrm>
+            <a:off x="731520" y="137160"/>
+            <a:ext cx="10515600" cy="594360"/>
+          </a:xfrm>
+          <a:prstGeom prst="rect">
+            <a:avLst/>
+          </a:prstGeom>
+          <a:noFill/>
+        </p:spPr>
+        <p:txBody>
+          <a:bodyPr wrap="none">
+            <a:spAutoFit/>
+          </a:bodyPr>
+          <a:lstStyle/>
+          <a:p>
+            <a:pPr algn="l">
+              <a:defRPr sz="2800" b="1">
+                <a:solidFill>
+                  <a:srgbClr val="FFFFFF"/>
+                </a:solidFill>
+              </a:defRPr>
+            </a:pPr>
+            <a:r>
               <a:t>Q&amp;A</a:t>
             </a:r>
           </a:p>
@@ -7035,7 +7351,7 @@
               </a:defRPr>
             </a:pPr>
             <a:r>
-              <a:t>20/20</a:t>
+              <a:t>21/21</a:t>
             </a:r>
           </a:p>
         </p:txBody>
@@ -7270,7 +7586,7 @@
               </a:defRPr>
             </a:pPr>
             <a:r>
-              <a:t>3/20</a:t>
+              <a:t>3/21</a:t>
             </a:r>
           </a:p>
         </p:txBody>
@@ -7570,7 +7886,7 @@
               </a:defRPr>
             </a:pPr>
             <a:r>
-              <a:t>4/20</a:t>
+              <a:t>4/21</a:t>
             </a:r>
           </a:p>
         </p:txBody>
@@ -7843,7 +8159,7 @@
               </a:defRPr>
             </a:pPr>
             <a:r>
-              <a:t>5/20</a:t>
+              <a:t>5/21</a:t>
             </a:r>
           </a:p>
         </p:txBody>
@@ -8160,7 +8476,7 @@
               </a:defRPr>
             </a:pPr>
             <a:r>
-              <a:t>6/20</a:t>
+              <a:t>6/21</a:t>
             </a:r>
           </a:p>
         </p:txBody>
@@ -8494,7 +8810,7 @@
               </a:defRPr>
             </a:pPr>
             <a:r>
-              <a:t>7/20</a:t>
+              <a:t>7/21</a:t>
             </a:r>
           </a:p>
         </p:txBody>
@@ -8804,7 +9120,7 @@
               </a:defRPr>
             </a:pPr>
             <a:r>
-              <a:t>8/20</a:t>
+              <a:t>8/21</a:t>
             </a:r>
           </a:p>
         </p:txBody>
@@ -9131,7 +9447,7 @@
               </a:defRPr>
             </a:pPr>
             <a:r>
-              <a:t>9/20</a:t>
+              <a:t>9/21</a:t>
             </a:r>
           </a:p>
         </p:txBody>

</xml_diff>

<commit_message>
feat: add workflow diagram slide to training PPT
New slide 17 (📥 Demand Workflow Diagram):
- Visual flowchart built with python-pptx shapes (rounded boxes + arrows)
- Shows all 3 value stream patterns: 2-step / 3-step / 4-step
- Terminal actions branching from final step: Approve / Backlog / Reject
- Convert modal path (Requirement or Backlog)
- Color-coded: blue=flow, green=approve, amber=backlog, red=reject, purple=convert
- Legend and key behaviors noted at bottom

PPT now 34 slides, 86KB (text-only, no screenshots)
</commit_message>
<xml_diff>
--- a/Training-PM-Tool.pptx
+++ b/Training-PM-Tool.pptx
@@ -38,6 +38,7 @@
     <p:sldId id="286" r:id="rId37"/>
     <p:sldId id="287" r:id="rId38"/>
     <p:sldId id="288" r:id="rId39"/>
+    <p:sldId id="289" r:id="rId40"/>
   </p:sldIdLst>
   <p:sldSz cx="12191695" cy="6858000" type="screen4x3"/>
   <p:notesSz cx="6858000" cy="9144000"/>
@@ -3288,7 +3289,7 @@
               </a:defRPr>
             </a:pPr>
             <a:r>
-              <a:t>1/33</a:t>
+              <a:t>1/34</a:t>
             </a:r>
           </a:p>
         </p:txBody>
@@ -3602,7 +3603,7 @@
               </a:defRPr>
             </a:pPr>
             <a:r>
-              <a:t>10/33</a:t>
+              <a:t>10/34</a:t>
             </a:r>
           </a:p>
         </p:txBody>
@@ -3916,7 +3917,7 @@
               </a:defRPr>
             </a:pPr>
             <a:r>
-              <a:t>11/33</a:t>
+              <a:t>11/34</a:t>
             </a:r>
           </a:p>
         </p:txBody>
@@ -4226,7 +4227,7 @@
               </a:defRPr>
             </a:pPr>
             <a:r>
-              <a:t>12/33</a:t>
+              <a:t>12/34</a:t>
             </a:r>
           </a:p>
         </p:txBody>
@@ -4536,7 +4537,7 @@
               </a:defRPr>
             </a:pPr>
             <a:r>
-              <a:t>13/33</a:t>
+              <a:t>13/34</a:t>
             </a:r>
           </a:p>
         </p:txBody>
@@ -4830,7 +4831,7 @@
               </a:defRPr>
             </a:pPr>
             <a:r>
-              <a:t>14/33</a:t>
+              <a:t>14/34</a:t>
             </a:r>
           </a:p>
         </p:txBody>
@@ -5137,7 +5138,7 @@
               </a:defRPr>
             </a:pPr>
             <a:r>
-              <a:t>15/33</a:t>
+              <a:t>15/34</a:t>
             </a:r>
           </a:p>
         </p:txBody>
@@ -5444,7 +5445,7 @@
               </a:defRPr>
             </a:pPr>
             <a:r>
-              <a:t>16/33</a:t>
+              <a:t>16/34</a:t>
             </a:r>
           </a:p>
         </p:txBody>
@@ -5583,7 +5584,7 @@
               </a:defRPr>
             </a:pPr>
             <a:r>
-              <a:t>🎯 Capabilities</a:t>
+              <a:t>📥 Demand Workflow Diagram</a:t>
             </a:r>
           </a:p>
         </p:txBody>
@@ -5618,21 +5619,1720 @@
               </a:defRPr>
             </a:pPr>
             <a:r>
-              <a:t>Business capability catalog</a:t>
-            </a:r>
-          </a:p>
-        </p:txBody>
-      </p:sp>
-      <p:sp>
-        <p:nvSpPr>
-          <p:cNvPr id="5" name="TextBox 4"/>
-          <p:cNvSpPr txBox="1"/>
-          <p:nvPr/>
-        </p:nvSpPr>
-        <p:spPr>
-          <a:xfrm>
-            <a:off x="731520" y="1371600"/>
-            <a:ext cx="10698480" cy="5029200"/>
+              <a:t>Flow steps → terminal actions → convert</a:t>
+            </a:r>
+          </a:p>
+        </p:txBody>
+      </p:sp>
+      <p:sp>
+        <p:nvSpPr>
+          <p:cNvPr id="5" name="Rounded Rectangle 4"/>
+          <p:cNvSpPr/>
+          <p:nvPr/>
+        </p:nvSpPr>
+        <p:spPr>
+          <a:xfrm>
+            <a:off x="274320" y="1188720"/>
+            <a:ext cx="11612880" cy="5303520"/>
+          </a:xfrm>
+          <a:prstGeom prst="roundRect">
+            <a:avLst/>
+          </a:prstGeom>
+          <a:solidFill>
+            <a:srgbClr val="F8FAFC"/>
+          </a:solidFill>
+          <a:ln w="12700">
+            <a:solidFill>
+              <a:srgbClr val="94A3B8"/>
+            </a:solidFill>
+          </a:ln>
+        </p:spPr>
+        <p:style>
+          <a:lnRef idx="1">
+            <a:schemeClr val="accent1"/>
+          </a:lnRef>
+          <a:fillRef idx="3">
+            <a:schemeClr val="accent1"/>
+          </a:fillRef>
+          <a:effectRef idx="2">
+            <a:schemeClr val="accent1"/>
+          </a:effectRef>
+          <a:fontRef idx="minor">
+            <a:schemeClr val="lt1"/>
+          </a:fontRef>
+        </p:style>
+        <p:txBody>
+          <a:bodyPr rtlCol="0" anchor="ctr"/>
+          <a:lstStyle/>
+          <a:p>
+            <a:pPr algn="ctr"/>
+          </a:p>
+        </p:txBody>
+      </p:sp>
+      <p:sp>
+        <p:nvSpPr>
+          <p:cNvPr id="6" name="TextBox 5"/>
+          <p:cNvSpPr txBox="1"/>
+          <p:nvPr/>
+        </p:nvSpPr>
+        <p:spPr>
+          <a:xfrm>
+            <a:off x="457200" y="1280160"/>
+            <a:ext cx="1828800" cy="228600"/>
+          </a:xfrm>
+          <a:prstGeom prst="rect">
+            <a:avLst/>
+          </a:prstGeom>
+          <a:noFill/>
+        </p:spPr>
+        <p:txBody>
+          <a:bodyPr wrap="none">
+            <a:spAutoFit/>
+          </a:bodyPr>
+          <a:lstStyle/>
+          <a:p>
+            <a:pPr>
+              <a:defRPr sz="1200" b="1">
+                <a:solidFill>
+                  <a:srgbClr val="64748B"/>
+                </a:solidFill>
+              </a:defRPr>
+            </a:pPr>
+            <a:r>
+              <a:t>Workflow Patterns by Value Stream</a:t>
+            </a:r>
+          </a:p>
+        </p:txBody>
+      </p:sp>
+      <p:sp>
+        <p:nvSpPr>
+          <p:cNvPr id="7" name="TextBox 6"/>
+          <p:cNvSpPr txBox="1"/>
+          <p:nvPr/>
+        </p:nvSpPr>
+        <p:spPr>
+          <a:xfrm>
+            <a:off x="457200" y="1600200"/>
+            <a:ext cx="4572000" cy="228600"/>
+          </a:xfrm>
+          <a:prstGeom prst="rect">
+            <a:avLst/>
+          </a:prstGeom>
+          <a:noFill/>
+        </p:spPr>
+        <p:txBody>
+          <a:bodyPr wrap="none">
+            <a:spAutoFit/>
+          </a:bodyPr>
+          <a:lstStyle/>
+          <a:p>
+            <a:pPr>
+              <a:defRPr sz="1000">
+                <a:solidFill>
+                  <a:srgbClr val="64748B"/>
+                </a:solidFill>
+              </a:defRPr>
+            </a:pPr>
+            <a:r>
+              <a:t>Customer Experience  (2 steps)</a:t>
+            </a:r>
+          </a:p>
+        </p:txBody>
+      </p:sp>
+      <p:sp>
+        <p:nvSpPr>
+          <p:cNvPr id="8" name="Rounded Rectangle 7"/>
+          <p:cNvSpPr/>
+          <p:nvPr/>
+        </p:nvSpPr>
+        <p:spPr>
+          <a:xfrm>
+            <a:off x="457200" y="1874519"/>
+            <a:ext cx="1188720" cy="365760"/>
+          </a:xfrm>
+          <a:prstGeom prst="roundRect">
+            <a:avLst/>
+          </a:prstGeom>
+          <a:solidFill>
+            <a:srgbClr val="6366F1"/>
+          </a:solidFill>
+          <a:ln>
+            <a:noFill/>
+          </a:ln>
+        </p:spPr>
+        <p:style>
+          <a:lnRef idx="1">
+            <a:schemeClr val="accent1"/>
+          </a:lnRef>
+          <a:fillRef idx="3">
+            <a:schemeClr val="accent1"/>
+          </a:fillRef>
+          <a:effectRef idx="2">
+            <a:schemeClr val="accent1"/>
+          </a:effectRef>
+          <a:fontRef idx="minor">
+            <a:schemeClr val="lt1"/>
+          </a:fontRef>
+        </p:style>
+        <p:txBody>
+          <a:bodyPr rtlCol="0" anchor="ctr" wrap="square" tIns="0" bIns="0"/>
+          <a:lstStyle/>
+          <a:p>
+            <a:pPr algn="ctr">
+              <a:defRPr sz="1100" b="1">
+                <a:solidFill>
+                  <a:srgbClr val="FFFFFF"/>
+                </a:solidFill>
+              </a:defRPr>
+            </a:pPr>
+            <a:r>
+              <a:t>Submitted</a:t>
+            </a:r>
+          </a:p>
+        </p:txBody>
+      </p:sp>
+      <p:sp>
+        <p:nvSpPr>
+          <p:cNvPr id="9" name="Right Arrow 8"/>
+          <p:cNvSpPr/>
+          <p:nvPr/>
+        </p:nvSpPr>
+        <p:spPr>
+          <a:xfrm>
+            <a:off x="1737360" y="1947672"/>
+            <a:ext cx="365760" cy="219456"/>
+          </a:xfrm>
+          <a:prstGeom prst="rightArrow">
+            <a:avLst/>
+          </a:prstGeom>
+          <a:solidFill>
+            <a:srgbClr val="64748B"/>
+          </a:solidFill>
+          <a:ln>
+            <a:noFill/>
+          </a:ln>
+        </p:spPr>
+        <p:style>
+          <a:lnRef idx="1">
+            <a:schemeClr val="accent1"/>
+          </a:lnRef>
+          <a:fillRef idx="3">
+            <a:schemeClr val="accent1"/>
+          </a:fillRef>
+          <a:effectRef idx="2">
+            <a:schemeClr val="accent1"/>
+          </a:effectRef>
+          <a:fontRef idx="minor">
+            <a:schemeClr val="lt1"/>
+          </a:fontRef>
+        </p:style>
+        <p:txBody>
+          <a:bodyPr rtlCol="0" anchor="ctr"/>
+          <a:lstStyle/>
+          <a:p>
+            <a:pPr algn="ctr"/>
+          </a:p>
+        </p:txBody>
+      </p:sp>
+      <p:sp>
+        <p:nvSpPr>
+          <p:cNvPr id="10" name="Rounded Rectangle 9"/>
+          <p:cNvSpPr/>
+          <p:nvPr/>
+        </p:nvSpPr>
+        <p:spPr>
+          <a:xfrm>
+            <a:off x="2194560" y="1874519"/>
+            <a:ext cx="1188720" cy="365760"/>
+          </a:xfrm>
+          <a:prstGeom prst="roundRect">
+            <a:avLst/>
+          </a:prstGeom>
+          <a:solidFill>
+            <a:srgbClr val="6366F1"/>
+          </a:solidFill>
+          <a:ln>
+            <a:noFill/>
+          </a:ln>
+        </p:spPr>
+        <p:style>
+          <a:lnRef idx="1">
+            <a:schemeClr val="accent1"/>
+          </a:lnRef>
+          <a:fillRef idx="3">
+            <a:schemeClr val="accent1"/>
+          </a:fillRef>
+          <a:effectRef idx="2">
+            <a:schemeClr val="accent1"/>
+          </a:effectRef>
+          <a:fontRef idx="minor">
+            <a:schemeClr val="lt1"/>
+          </a:fontRef>
+        </p:style>
+        <p:txBody>
+          <a:bodyPr rtlCol="0" anchor="ctr" wrap="square" tIns="0" bIns="0"/>
+          <a:lstStyle/>
+          <a:p>
+            <a:pPr algn="ctr">
+              <a:defRPr sz="1100" b="1">
+                <a:solidFill>
+                  <a:srgbClr val="FFFFFF"/>
+                </a:solidFill>
+              </a:defRPr>
+            </a:pPr>
+            <a:r>
+              <a:t>Triaging</a:t>
+            </a:r>
+          </a:p>
+        </p:txBody>
+      </p:sp>
+      <p:sp>
+        <p:nvSpPr>
+          <p:cNvPr id="11" name="Down Arrow 10"/>
+          <p:cNvSpPr/>
+          <p:nvPr/>
+        </p:nvSpPr>
+        <p:spPr>
+          <a:xfrm>
+            <a:off x="2697480" y="2258568"/>
+            <a:ext cx="182880" cy="274320"/>
+          </a:xfrm>
+          <a:prstGeom prst="downArrow">
+            <a:avLst/>
+          </a:prstGeom>
+          <a:solidFill>
+            <a:srgbClr val="64748B"/>
+          </a:solidFill>
+          <a:ln>
+            <a:noFill/>
+          </a:ln>
+        </p:spPr>
+        <p:style>
+          <a:lnRef idx="1">
+            <a:schemeClr val="accent1"/>
+          </a:lnRef>
+          <a:fillRef idx="3">
+            <a:schemeClr val="accent1"/>
+          </a:fillRef>
+          <a:effectRef idx="2">
+            <a:schemeClr val="accent1"/>
+          </a:effectRef>
+          <a:fontRef idx="minor">
+            <a:schemeClr val="lt1"/>
+          </a:fontRef>
+        </p:style>
+        <p:txBody>
+          <a:bodyPr rtlCol="0" anchor="ctr"/>
+          <a:lstStyle/>
+          <a:p>
+            <a:pPr algn="ctr"/>
+          </a:p>
+        </p:txBody>
+      </p:sp>
+      <p:sp>
+        <p:nvSpPr>
+          <p:cNvPr id="12" name="TextBox 11"/>
+          <p:cNvSpPr txBox="1"/>
+          <p:nvPr/>
+        </p:nvSpPr>
+        <p:spPr>
+          <a:xfrm>
+            <a:off x="2331720" y="2560320"/>
+            <a:ext cx="1371600" cy="182880"/>
+          </a:xfrm>
+          <a:prstGeom prst="rect">
+            <a:avLst/>
+          </a:prstGeom>
+          <a:noFill/>
+        </p:spPr>
+        <p:txBody>
+          <a:bodyPr wrap="none">
+            <a:spAutoFit/>
+          </a:bodyPr>
+          <a:lstStyle/>
+          <a:p>
+            <a:pPr algn="ctr">
+              <a:defRPr sz="700">
+                <a:solidFill>
+                  <a:srgbClr val="64748B"/>
+                </a:solidFill>
+              </a:defRPr>
+            </a:pPr>
+            <a:r>
+              <a:t>Terminal &gt;&gt;</a:t>
+            </a:r>
+          </a:p>
+        </p:txBody>
+      </p:sp>
+      <p:sp>
+        <p:nvSpPr>
+          <p:cNvPr id="13" name="TextBox 12"/>
+          <p:cNvSpPr txBox="1"/>
+          <p:nvPr/>
+        </p:nvSpPr>
+        <p:spPr>
+          <a:xfrm>
+            <a:off x="457200" y="2377440"/>
+            <a:ext cx="4572000" cy="228600"/>
+          </a:xfrm>
+          <a:prstGeom prst="rect">
+            <a:avLst/>
+          </a:prstGeom>
+          <a:noFill/>
+        </p:spPr>
+        <p:txBody>
+          <a:bodyPr wrap="none">
+            <a:spAutoFit/>
+          </a:bodyPr>
+          <a:lstStyle/>
+          <a:p>
+            <a:pPr>
+              <a:defRPr sz="1000">
+                <a:solidFill>
+                  <a:srgbClr val="64748B"/>
+                </a:solidFill>
+              </a:defRPr>
+            </a:pPr>
+            <a:r>
+              <a:t>Operational Efficiency  (3 steps)</a:t>
+            </a:r>
+          </a:p>
+        </p:txBody>
+      </p:sp>
+      <p:sp>
+        <p:nvSpPr>
+          <p:cNvPr id="14" name="Rounded Rectangle 13"/>
+          <p:cNvSpPr/>
+          <p:nvPr/>
+        </p:nvSpPr>
+        <p:spPr>
+          <a:xfrm>
+            <a:off x="457200" y="2651760"/>
+            <a:ext cx="1188720" cy="365760"/>
+          </a:xfrm>
+          <a:prstGeom prst="roundRect">
+            <a:avLst/>
+          </a:prstGeom>
+          <a:solidFill>
+            <a:srgbClr val="6366F1"/>
+          </a:solidFill>
+          <a:ln>
+            <a:noFill/>
+          </a:ln>
+        </p:spPr>
+        <p:style>
+          <a:lnRef idx="1">
+            <a:schemeClr val="accent1"/>
+          </a:lnRef>
+          <a:fillRef idx="3">
+            <a:schemeClr val="accent1"/>
+          </a:fillRef>
+          <a:effectRef idx="2">
+            <a:schemeClr val="accent1"/>
+          </a:effectRef>
+          <a:fontRef idx="minor">
+            <a:schemeClr val="lt1"/>
+          </a:fontRef>
+        </p:style>
+        <p:txBody>
+          <a:bodyPr rtlCol="0" anchor="ctr" wrap="square" tIns="0" bIns="0"/>
+          <a:lstStyle/>
+          <a:p>
+            <a:pPr algn="ctr">
+              <a:defRPr sz="1100" b="1">
+                <a:solidFill>
+                  <a:srgbClr val="FFFFFF"/>
+                </a:solidFill>
+              </a:defRPr>
+            </a:pPr>
+            <a:r>
+              <a:t>Submitted</a:t>
+            </a:r>
+          </a:p>
+        </p:txBody>
+      </p:sp>
+      <p:sp>
+        <p:nvSpPr>
+          <p:cNvPr id="15" name="Right Arrow 14"/>
+          <p:cNvSpPr/>
+          <p:nvPr/>
+        </p:nvSpPr>
+        <p:spPr>
+          <a:xfrm>
+            <a:off x="1737360" y="2724912"/>
+            <a:ext cx="365760" cy="219456"/>
+          </a:xfrm>
+          <a:prstGeom prst="rightArrow">
+            <a:avLst/>
+          </a:prstGeom>
+          <a:solidFill>
+            <a:srgbClr val="64748B"/>
+          </a:solidFill>
+          <a:ln>
+            <a:noFill/>
+          </a:ln>
+        </p:spPr>
+        <p:style>
+          <a:lnRef idx="1">
+            <a:schemeClr val="accent1"/>
+          </a:lnRef>
+          <a:fillRef idx="3">
+            <a:schemeClr val="accent1"/>
+          </a:fillRef>
+          <a:effectRef idx="2">
+            <a:schemeClr val="accent1"/>
+          </a:effectRef>
+          <a:fontRef idx="minor">
+            <a:schemeClr val="lt1"/>
+          </a:fontRef>
+        </p:style>
+        <p:txBody>
+          <a:bodyPr rtlCol="0" anchor="ctr"/>
+          <a:lstStyle/>
+          <a:p>
+            <a:pPr algn="ctr"/>
+          </a:p>
+        </p:txBody>
+      </p:sp>
+      <p:sp>
+        <p:nvSpPr>
+          <p:cNvPr id="16" name="Rounded Rectangle 15"/>
+          <p:cNvSpPr/>
+          <p:nvPr/>
+        </p:nvSpPr>
+        <p:spPr>
+          <a:xfrm>
+            <a:off x="2194560" y="2651760"/>
+            <a:ext cx="1188720" cy="365760"/>
+          </a:xfrm>
+          <a:prstGeom prst="roundRect">
+            <a:avLst/>
+          </a:prstGeom>
+          <a:solidFill>
+            <a:srgbClr val="6366F1"/>
+          </a:solidFill>
+          <a:ln>
+            <a:noFill/>
+          </a:ln>
+        </p:spPr>
+        <p:style>
+          <a:lnRef idx="1">
+            <a:schemeClr val="accent1"/>
+          </a:lnRef>
+          <a:fillRef idx="3">
+            <a:schemeClr val="accent1"/>
+          </a:fillRef>
+          <a:effectRef idx="2">
+            <a:schemeClr val="accent1"/>
+          </a:effectRef>
+          <a:fontRef idx="minor">
+            <a:schemeClr val="lt1"/>
+          </a:fontRef>
+        </p:style>
+        <p:txBody>
+          <a:bodyPr rtlCol="0" anchor="ctr" wrap="square" tIns="0" bIns="0"/>
+          <a:lstStyle/>
+          <a:p>
+            <a:pPr algn="ctr">
+              <a:defRPr sz="1100" b="1">
+                <a:solidFill>
+                  <a:srgbClr val="FFFFFF"/>
+                </a:solidFill>
+              </a:defRPr>
+            </a:pPr>
+            <a:r>
+              <a:t>Triaging</a:t>
+            </a:r>
+          </a:p>
+        </p:txBody>
+      </p:sp>
+      <p:sp>
+        <p:nvSpPr>
+          <p:cNvPr id="17" name="Right Arrow 16"/>
+          <p:cNvSpPr/>
+          <p:nvPr/>
+        </p:nvSpPr>
+        <p:spPr>
+          <a:xfrm>
+            <a:off x="3474720" y="2724912"/>
+            <a:ext cx="365760" cy="219456"/>
+          </a:xfrm>
+          <a:prstGeom prst="rightArrow">
+            <a:avLst/>
+          </a:prstGeom>
+          <a:solidFill>
+            <a:srgbClr val="64748B"/>
+          </a:solidFill>
+          <a:ln>
+            <a:noFill/>
+          </a:ln>
+        </p:spPr>
+        <p:style>
+          <a:lnRef idx="1">
+            <a:schemeClr val="accent1"/>
+          </a:lnRef>
+          <a:fillRef idx="3">
+            <a:schemeClr val="accent1"/>
+          </a:fillRef>
+          <a:effectRef idx="2">
+            <a:schemeClr val="accent1"/>
+          </a:effectRef>
+          <a:fontRef idx="minor">
+            <a:schemeClr val="lt1"/>
+          </a:fontRef>
+        </p:style>
+        <p:txBody>
+          <a:bodyPr rtlCol="0" anchor="ctr"/>
+          <a:lstStyle/>
+          <a:p>
+            <a:pPr algn="ctr"/>
+          </a:p>
+        </p:txBody>
+      </p:sp>
+      <p:sp>
+        <p:nvSpPr>
+          <p:cNvPr id="18" name="Rounded Rectangle 17"/>
+          <p:cNvSpPr/>
+          <p:nvPr/>
+        </p:nvSpPr>
+        <p:spPr>
+          <a:xfrm>
+            <a:off x="3931920" y="2651760"/>
+            <a:ext cx="1188720" cy="365760"/>
+          </a:xfrm>
+          <a:prstGeom prst="roundRect">
+            <a:avLst/>
+          </a:prstGeom>
+          <a:solidFill>
+            <a:srgbClr val="6366F1"/>
+          </a:solidFill>
+          <a:ln>
+            <a:noFill/>
+          </a:ln>
+        </p:spPr>
+        <p:style>
+          <a:lnRef idx="1">
+            <a:schemeClr val="accent1"/>
+          </a:lnRef>
+          <a:fillRef idx="3">
+            <a:schemeClr val="accent1"/>
+          </a:fillRef>
+          <a:effectRef idx="2">
+            <a:schemeClr val="accent1"/>
+          </a:effectRef>
+          <a:fontRef idx="minor">
+            <a:schemeClr val="lt1"/>
+          </a:fontRef>
+        </p:style>
+        <p:txBody>
+          <a:bodyPr rtlCol="0" anchor="ctr" wrap="square" tIns="0" bIns="0"/>
+          <a:lstStyle/>
+          <a:p>
+            <a:pPr algn="ctr">
+              <a:defRPr sz="1100" b="1">
+                <a:solidFill>
+                  <a:srgbClr val="FFFFFF"/>
+                </a:solidFill>
+              </a:defRPr>
+            </a:pPr>
+            <a:r>
+              <a:t>Assessed</a:t>
+            </a:r>
+          </a:p>
+        </p:txBody>
+      </p:sp>
+      <p:sp>
+        <p:nvSpPr>
+          <p:cNvPr id="19" name="Down Arrow 18"/>
+          <p:cNvSpPr/>
+          <p:nvPr/>
+        </p:nvSpPr>
+        <p:spPr>
+          <a:xfrm>
+            <a:off x="4434840" y="3035808"/>
+            <a:ext cx="182880" cy="274320"/>
+          </a:xfrm>
+          <a:prstGeom prst="downArrow">
+            <a:avLst/>
+          </a:prstGeom>
+          <a:solidFill>
+            <a:srgbClr val="64748B"/>
+          </a:solidFill>
+          <a:ln>
+            <a:noFill/>
+          </a:ln>
+        </p:spPr>
+        <p:style>
+          <a:lnRef idx="1">
+            <a:schemeClr val="accent1"/>
+          </a:lnRef>
+          <a:fillRef idx="3">
+            <a:schemeClr val="accent1"/>
+          </a:fillRef>
+          <a:effectRef idx="2">
+            <a:schemeClr val="accent1"/>
+          </a:effectRef>
+          <a:fontRef idx="minor">
+            <a:schemeClr val="lt1"/>
+          </a:fontRef>
+        </p:style>
+        <p:txBody>
+          <a:bodyPr rtlCol="0" anchor="ctr"/>
+          <a:lstStyle/>
+          <a:p>
+            <a:pPr algn="ctr"/>
+          </a:p>
+        </p:txBody>
+      </p:sp>
+      <p:sp>
+        <p:nvSpPr>
+          <p:cNvPr id="20" name="TextBox 19"/>
+          <p:cNvSpPr txBox="1"/>
+          <p:nvPr/>
+        </p:nvSpPr>
+        <p:spPr>
+          <a:xfrm>
+            <a:off x="4069080" y="3337560"/>
+            <a:ext cx="1371600" cy="182880"/>
+          </a:xfrm>
+          <a:prstGeom prst="rect">
+            <a:avLst/>
+          </a:prstGeom>
+          <a:noFill/>
+        </p:spPr>
+        <p:txBody>
+          <a:bodyPr wrap="none">
+            <a:spAutoFit/>
+          </a:bodyPr>
+          <a:lstStyle/>
+          <a:p>
+            <a:pPr algn="ctr">
+              <a:defRPr sz="700">
+                <a:solidFill>
+                  <a:srgbClr val="64748B"/>
+                </a:solidFill>
+              </a:defRPr>
+            </a:pPr>
+            <a:r>
+              <a:t>Terminal &gt;&gt;</a:t>
+            </a:r>
+          </a:p>
+        </p:txBody>
+      </p:sp>
+      <p:sp>
+        <p:nvSpPr>
+          <p:cNvPr id="21" name="TextBox 20"/>
+          <p:cNvSpPr txBox="1"/>
+          <p:nvPr/>
+        </p:nvSpPr>
+        <p:spPr>
+          <a:xfrm>
+            <a:off x="457200" y="3154680"/>
+            <a:ext cx="4572000" cy="228600"/>
+          </a:xfrm>
+          <a:prstGeom prst="rect">
+            <a:avLst/>
+          </a:prstGeom>
+          <a:noFill/>
+        </p:spPr>
+        <p:txBody>
+          <a:bodyPr wrap="none">
+            <a:spAutoFit/>
+          </a:bodyPr>
+          <a:lstStyle/>
+          <a:p>
+            <a:pPr>
+              <a:defRPr sz="1000">
+                <a:solidFill>
+                  <a:srgbClr val="64748B"/>
+                </a:solidFill>
+              </a:defRPr>
+            </a:pPr>
+            <a:r>
+              <a:t>Risk &amp; Compliance  (4 steps)</a:t>
+            </a:r>
+          </a:p>
+        </p:txBody>
+      </p:sp>
+      <p:sp>
+        <p:nvSpPr>
+          <p:cNvPr id="22" name="Rounded Rectangle 21"/>
+          <p:cNvSpPr/>
+          <p:nvPr/>
+        </p:nvSpPr>
+        <p:spPr>
+          <a:xfrm>
+            <a:off x="457200" y="3429000"/>
+            <a:ext cx="1188720" cy="365760"/>
+          </a:xfrm>
+          <a:prstGeom prst="roundRect">
+            <a:avLst/>
+          </a:prstGeom>
+          <a:solidFill>
+            <a:srgbClr val="6366F1"/>
+          </a:solidFill>
+          <a:ln>
+            <a:noFill/>
+          </a:ln>
+        </p:spPr>
+        <p:style>
+          <a:lnRef idx="1">
+            <a:schemeClr val="accent1"/>
+          </a:lnRef>
+          <a:fillRef idx="3">
+            <a:schemeClr val="accent1"/>
+          </a:fillRef>
+          <a:effectRef idx="2">
+            <a:schemeClr val="accent1"/>
+          </a:effectRef>
+          <a:fontRef idx="minor">
+            <a:schemeClr val="lt1"/>
+          </a:fontRef>
+        </p:style>
+        <p:txBody>
+          <a:bodyPr rtlCol="0" anchor="ctr" wrap="square" tIns="0" bIns="0"/>
+          <a:lstStyle/>
+          <a:p>
+            <a:pPr algn="ctr">
+              <a:defRPr sz="1100" b="1">
+                <a:solidFill>
+                  <a:srgbClr val="FFFFFF"/>
+                </a:solidFill>
+              </a:defRPr>
+            </a:pPr>
+            <a:r>
+              <a:t>Submitted</a:t>
+            </a:r>
+          </a:p>
+        </p:txBody>
+      </p:sp>
+      <p:sp>
+        <p:nvSpPr>
+          <p:cNvPr id="23" name="Right Arrow 22"/>
+          <p:cNvSpPr/>
+          <p:nvPr/>
+        </p:nvSpPr>
+        <p:spPr>
+          <a:xfrm>
+            <a:off x="1737360" y="3502152"/>
+            <a:ext cx="365760" cy="219456"/>
+          </a:xfrm>
+          <a:prstGeom prst="rightArrow">
+            <a:avLst/>
+          </a:prstGeom>
+          <a:solidFill>
+            <a:srgbClr val="64748B"/>
+          </a:solidFill>
+          <a:ln>
+            <a:noFill/>
+          </a:ln>
+        </p:spPr>
+        <p:style>
+          <a:lnRef idx="1">
+            <a:schemeClr val="accent1"/>
+          </a:lnRef>
+          <a:fillRef idx="3">
+            <a:schemeClr val="accent1"/>
+          </a:fillRef>
+          <a:effectRef idx="2">
+            <a:schemeClr val="accent1"/>
+          </a:effectRef>
+          <a:fontRef idx="minor">
+            <a:schemeClr val="lt1"/>
+          </a:fontRef>
+        </p:style>
+        <p:txBody>
+          <a:bodyPr rtlCol="0" anchor="ctr"/>
+          <a:lstStyle/>
+          <a:p>
+            <a:pPr algn="ctr"/>
+          </a:p>
+        </p:txBody>
+      </p:sp>
+      <p:sp>
+        <p:nvSpPr>
+          <p:cNvPr id="24" name="Rounded Rectangle 23"/>
+          <p:cNvSpPr/>
+          <p:nvPr/>
+        </p:nvSpPr>
+        <p:spPr>
+          <a:xfrm>
+            <a:off x="2194560" y="3429000"/>
+            <a:ext cx="1188720" cy="365760"/>
+          </a:xfrm>
+          <a:prstGeom prst="roundRect">
+            <a:avLst/>
+          </a:prstGeom>
+          <a:solidFill>
+            <a:srgbClr val="6366F1"/>
+          </a:solidFill>
+          <a:ln>
+            <a:noFill/>
+          </a:ln>
+        </p:spPr>
+        <p:style>
+          <a:lnRef idx="1">
+            <a:schemeClr val="accent1"/>
+          </a:lnRef>
+          <a:fillRef idx="3">
+            <a:schemeClr val="accent1"/>
+          </a:fillRef>
+          <a:effectRef idx="2">
+            <a:schemeClr val="accent1"/>
+          </a:effectRef>
+          <a:fontRef idx="minor">
+            <a:schemeClr val="lt1"/>
+          </a:fontRef>
+        </p:style>
+        <p:txBody>
+          <a:bodyPr rtlCol="0" anchor="ctr" wrap="square" tIns="0" bIns="0"/>
+          <a:lstStyle/>
+          <a:p>
+            <a:pPr algn="ctr">
+              <a:defRPr sz="1100" b="1">
+                <a:solidFill>
+                  <a:srgbClr val="FFFFFF"/>
+                </a:solidFill>
+              </a:defRPr>
+            </a:pPr>
+            <a:r>
+              <a:t>Triaging</a:t>
+            </a:r>
+          </a:p>
+        </p:txBody>
+      </p:sp>
+      <p:sp>
+        <p:nvSpPr>
+          <p:cNvPr id="25" name="Right Arrow 24"/>
+          <p:cNvSpPr/>
+          <p:nvPr/>
+        </p:nvSpPr>
+        <p:spPr>
+          <a:xfrm>
+            <a:off x="3474720" y="3502152"/>
+            <a:ext cx="365760" cy="219456"/>
+          </a:xfrm>
+          <a:prstGeom prst="rightArrow">
+            <a:avLst/>
+          </a:prstGeom>
+          <a:solidFill>
+            <a:srgbClr val="64748B"/>
+          </a:solidFill>
+          <a:ln>
+            <a:noFill/>
+          </a:ln>
+        </p:spPr>
+        <p:style>
+          <a:lnRef idx="1">
+            <a:schemeClr val="accent1"/>
+          </a:lnRef>
+          <a:fillRef idx="3">
+            <a:schemeClr val="accent1"/>
+          </a:fillRef>
+          <a:effectRef idx="2">
+            <a:schemeClr val="accent1"/>
+          </a:effectRef>
+          <a:fontRef idx="minor">
+            <a:schemeClr val="lt1"/>
+          </a:fontRef>
+        </p:style>
+        <p:txBody>
+          <a:bodyPr rtlCol="0" anchor="ctr"/>
+          <a:lstStyle/>
+          <a:p>
+            <a:pPr algn="ctr"/>
+          </a:p>
+        </p:txBody>
+      </p:sp>
+      <p:sp>
+        <p:nvSpPr>
+          <p:cNvPr id="26" name="Rounded Rectangle 25"/>
+          <p:cNvSpPr/>
+          <p:nvPr/>
+        </p:nvSpPr>
+        <p:spPr>
+          <a:xfrm>
+            <a:off x="3931920" y="3429000"/>
+            <a:ext cx="1188720" cy="365760"/>
+          </a:xfrm>
+          <a:prstGeom prst="roundRect">
+            <a:avLst/>
+          </a:prstGeom>
+          <a:solidFill>
+            <a:srgbClr val="6366F1"/>
+          </a:solidFill>
+          <a:ln>
+            <a:noFill/>
+          </a:ln>
+        </p:spPr>
+        <p:style>
+          <a:lnRef idx="1">
+            <a:schemeClr val="accent1"/>
+          </a:lnRef>
+          <a:fillRef idx="3">
+            <a:schemeClr val="accent1"/>
+          </a:fillRef>
+          <a:effectRef idx="2">
+            <a:schemeClr val="accent1"/>
+          </a:effectRef>
+          <a:fontRef idx="minor">
+            <a:schemeClr val="lt1"/>
+          </a:fontRef>
+        </p:style>
+        <p:txBody>
+          <a:bodyPr rtlCol="0" anchor="ctr" wrap="square" tIns="0" bIns="0"/>
+          <a:lstStyle/>
+          <a:p>
+            <a:pPr algn="ctr">
+              <a:defRPr sz="1100" b="1">
+                <a:solidFill>
+                  <a:srgbClr val="FFFFFF"/>
+                </a:solidFill>
+              </a:defRPr>
+            </a:pPr>
+            <a:r>
+              <a:t>Assessed</a:t>
+            </a:r>
+          </a:p>
+        </p:txBody>
+      </p:sp>
+      <p:sp>
+        <p:nvSpPr>
+          <p:cNvPr id="27" name="Right Arrow 26"/>
+          <p:cNvSpPr/>
+          <p:nvPr/>
+        </p:nvSpPr>
+        <p:spPr>
+          <a:xfrm>
+            <a:off x="5212080" y="3502152"/>
+            <a:ext cx="365760" cy="219456"/>
+          </a:xfrm>
+          <a:prstGeom prst="rightArrow">
+            <a:avLst/>
+          </a:prstGeom>
+          <a:solidFill>
+            <a:srgbClr val="64748B"/>
+          </a:solidFill>
+          <a:ln>
+            <a:noFill/>
+          </a:ln>
+        </p:spPr>
+        <p:style>
+          <a:lnRef idx="1">
+            <a:schemeClr val="accent1"/>
+          </a:lnRef>
+          <a:fillRef idx="3">
+            <a:schemeClr val="accent1"/>
+          </a:fillRef>
+          <a:effectRef idx="2">
+            <a:schemeClr val="accent1"/>
+          </a:effectRef>
+          <a:fontRef idx="minor">
+            <a:schemeClr val="lt1"/>
+          </a:fontRef>
+        </p:style>
+        <p:txBody>
+          <a:bodyPr rtlCol="0" anchor="ctr"/>
+          <a:lstStyle/>
+          <a:p>
+            <a:pPr algn="ctr"/>
+          </a:p>
+        </p:txBody>
+      </p:sp>
+      <p:sp>
+        <p:nvSpPr>
+          <p:cNvPr id="28" name="Rounded Rectangle 27"/>
+          <p:cNvSpPr/>
+          <p:nvPr/>
+        </p:nvSpPr>
+        <p:spPr>
+          <a:xfrm>
+            <a:off x="5669280" y="3429000"/>
+            <a:ext cx="1188720" cy="365760"/>
+          </a:xfrm>
+          <a:prstGeom prst="roundRect">
+            <a:avLst/>
+          </a:prstGeom>
+          <a:solidFill>
+            <a:srgbClr val="6366F1"/>
+          </a:solidFill>
+          <a:ln>
+            <a:noFill/>
+          </a:ln>
+        </p:spPr>
+        <p:style>
+          <a:lnRef idx="1">
+            <a:schemeClr val="accent1"/>
+          </a:lnRef>
+          <a:fillRef idx="3">
+            <a:schemeClr val="accent1"/>
+          </a:fillRef>
+          <a:effectRef idx="2">
+            <a:schemeClr val="accent1"/>
+          </a:effectRef>
+          <a:fontRef idx="minor">
+            <a:schemeClr val="lt1"/>
+          </a:fontRef>
+        </p:style>
+        <p:txBody>
+          <a:bodyPr rtlCol="0" anchor="ctr" wrap="square" tIns="0" bIns="0"/>
+          <a:lstStyle/>
+          <a:p>
+            <a:pPr algn="ctr">
+              <a:defRPr sz="1100" b="1">
+                <a:solidFill>
+                  <a:srgbClr val="FFFFFF"/>
+                </a:solidFill>
+              </a:defRPr>
+            </a:pPr>
+            <a:r>
+              <a:t>PSC Review</a:t>
+            </a:r>
+          </a:p>
+        </p:txBody>
+      </p:sp>
+      <p:sp>
+        <p:nvSpPr>
+          <p:cNvPr id="29" name="Down Arrow 28"/>
+          <p:cNvSpPr/>
+          <p:nvPr/>
+        </p:nvSpPr>
+        <p:spPr>
+          <a:xfrm>
+            <a:off x="6172200" y="3813048"/>
+            <a:ext cx="182880" cy="274320"/>
+          </a:xfrm>
+          <a:prstGeom prst="downArrow">
+            <a:avLst/>
+          </a:prstGeom>
+          <a:solidFill>
+            <a:srgbClr val="64748B"/>
+          </a:solidFill>
+          <a:ln>
+            <a:noFill/>
+          </a:ln>
+        </p:spPr>
+        <p:style>
+          <a:lnRef idx="1">
+            <a:schemeClr val="accent1"/>
+          </a:lnRef>
+          <a:fillRef idx="3">
+            <a:schemeClr val="accent1"/>
+          </a:fillRef>
+          <a:effectRef idx="2">
+            <a:schemeClr val="accent1"/>
+          </a:effectRef>
+          <a:fontRef idx="minor">
+            <a:schemeClr val="lt1"/>
+          </a:fontRef>
+        </p:style>
+        <p:txBody>
+          <a:bodyPr rtlCol="0" anchor="ctr"/>
+          <a:lstStyle/>
+          <a:p>
+            <a:pPr algn="ctr"/>
+          </a:p>
+        </p:txBody>
+      </p:sp>
+      <p:sp>
+        <p:nvSpPr>
+          <p:cNvPr id="30" name="TextBox 29"/>
+          <p:cNvSpPr txBox="1"/>
+          <p:nvPr/>
+        </p:nvSpPr>
+        <p:spPr>
+          <a:xfrm>
+            <a:off x="5806440" y="4114800"/>
+            <a:ext cx="1371600" cy="182880"/>
+          </a:xfrm>
+          <a:prstGeom prst="rect">
+            <a:avLst/>
+          </a:prstGeom>
+          <a:noFill/>
+        </p:spPr>
+        <p:txBody>
+          <a:bodyPr wrap="none">
+            <a:spAutoFit/>
+          </a:bodyPr>
+          <a:lstStyle/>
+          <a:p>
+            <a:pPr algn="ctr">
+              <a:defRPr sz="700">
+                <a:solidFill>
+                  <a:srgbClr val="64748B"/>
+                </a:solidFill>
+              </a:defRPr>
+            </a:pPr>
+            <a:r>
+              <a:t>Terminal &gt;&gt;</a:t>
+            </a:r>
+          </a:p>
+        </p:txBody>
+      </p:sp>
+      <p:sp>
+        <p:nvSpPr>
+          <p:cNvPr id="31" name="Rounded Rectangle 30"/>
+          <p:cNvSpPr/>
+          <p:nvPr/>
+        </p:nvSpPr>
+        <p:spPr>
+          <a:xfrm>
+            <a:off x="7315200" y="1508760"/>
+            <a:ext cx="1371600" cy="502920"/>
+          </a:xfrm>
+          <a:prstGeom prst="roundRect">
+            <a:avLst/>
+          </a:prstGeom>
+          <a:solidFill>
+            <a:srgbClr val="22C55E"/>
+          </a:solidFill>
+          <a:ln>
+            <a:noFill/>
+          </a:ln>
+        </p:spPr>
+        <p:style>
+          <a:lnRef idx="1">
+            <a:schemeClr val="accent1"/>
+          </a:lnRef>
+          <a:fillRef idx="3">
+            <a:schemeClr val="accent1"/>
+          </a:fillRef>
+          <a:effectRef idx="2">
+            <a:schemeClr val="accent1"/>
+          </a:effectRef>
+          <a:fontRef idx="minor">
+            <a:schemeClr val="lt1"/>
+          </a:fontRef>
+        </p:style>
+        <p:txBody>
+          <a:bodyPr rtlCol="0" anchor="ctr" wrap="square" tIns="0" bIns="0"/>
+          <a:lstStyle/>
+          <a:p>
+            <a:pPr algn="ctr">
+              <a:defRPr sz="1100" b="1">
+                <a:solidFill>
+                  <a:srgbClr val="FFFFFF"/>
+                </a:solidFill>
+              </a:defRPr>
+            </a:pPr>
+            <a:r>
+              <a:t>✅ Approve</a:t>
+            </a:r>
+          </a:p>
+        </p:txBody>
+      </p:sp>
+      <p:sp>
+        <p:nvSpPr>
+          <p:cNvPr id="32" name="Rounded Rectangle 31"/>
+          <p:cNvSpPr/>
+          <p:nvPr/>
+        </p:nvSpPr>
+        <p:spPr>
+          <a:xfrm>
+            <a:off x="7315200" y="2194560"/>
+            <a:ext cx="1371600" cy="502920"/>
+          </a:xfrm>
+          <a:prstGeom prst="roundRect">
+            <a:avLst/>
+          </a:prstGeom>
+          <a:solidFill>
+            <a:srgbClr val="EAB308"/>
+          </a:solidFill>
+          <a:ln>
+            <a:noFill/>
+          </a:ln>
+        </p:spPr>
+        <p:style>
+          <a:lnRef idx="1">
+            <a:schemeClr val="accent1"/>
+          </a:lnRef>
+          <a:fillRef idx="3">
+            <a:schemeClr val="accent1"/>
+          </a:fillRef>
+          <a:effectRef idx="2">
+            <a:schemeClr val="accent1"/>
+          </a:effectRef>
+          <a:fontRef idx="minor">
+            <a:schemeClr val="lt1"/>
+          </a:fontRef>
+        </p:style>
+        <p:txBody>
+          <a:bodyPr rtlCol="0" anchor="ctr" wrap="square" tIns="0" bIns="0"/>
+          <a:lstStyle/>
+          <a:p>
+            <a:pPr algn="ctr">
+              <a:defRPr sz="1100" b="1">
+                <a:solidFill>
+                  <a:srgbClr val="FFFFFF"/>
+                </a:solidFill>
+              </a:defRPr>
+            </a:pPr>
+            <a:r>
+              <a:t>📥 Backlog</a:t>
+            </a:r>
+          </a:p>
+        </p:txBody>
+      </p:sp>
+      <p:sp>
+        <p:nvSpPr>
+          <p:cNvPr id="33" name="Rounded Rectangle 32"/>
+          <p:cNvSpPr/>
+          <p:nvPr/>
+        </p:nvSpPr>
+        <p:spPr>
+          <a:xfrm>
+            <a:off x="7315200" y="2880360"/>
+            <a:ext cx="1371600" cy="502920"/>
+          </a:xfrm>
+          <a:prstGeom prst="roundRect">
+            <a:avLst/>
+          </a:prstGeom>
+          <a:solidFill>
+            <a:srgbClr val="EF4444"/>
+          </a:solidFill>
+          <a:ln>
+            <a:noFill/>
+          </a:ln>
+        </p:spPr>
+        <p:style>
+          <a:lnRef idx="1">
+            <a:schemeClr val="accent1"/>
+          </a:lnRef>
+          <a:fillRef idx="3">
+            <a:schemeClr val="accent1"/>
+          </a:fillRef>
+          <a:effectRef idx="2">
+            <a:schemeClr val="accent1"/>
+          </a:effectRef>
+          <a:fontRef idx="minor">
+            <a:schemeClr val="lt1"/>
+          </a:fontRef>
+        </p:style>
+        <p:txBody>
+          <a:bodyPr rtlCol="0" anchor="ctr" wrap="square" tIns="0" bIns="0"/>
+          <a:lstStyle/>
+          <a:p>
+            <a:pPr algn="ctr">
+              <a:defRPr sz="1100" b="1">
+                <a:solidFill>
+                  <a:srgbClr val="FFFFFF"/>
+                </a:solidFill>
+              </a:defRPr>
+            </a:pPr>
+            <a:r>
+              <a:t>❌ Reject</a:t>
+            </a:r>
+          </a:p>
+        </p:txBody>
+      </p:sp>
+      <p:sp>
+        <p:nvSpPr>
+          <p:cNvPr id="34" name="Down Arrow 33"/>
+          <p:cNvSpPr/>
+          <p:nvPr/>
+        </p:nvSpPr>
+        <p:spPr>
+          <a:xfrm>
+            <a:off x="7909560" y="2039112"/>
+            <a:ext cx="182880" cy="137160"/>
+          </a:xfrm>
+          <a:prstGeom prst="downArrow">
+            <a:avLst/>
+          </a:prstGeom>
+          <a:solidFill>
+            <a:srgbClr val="22C55E"/>
+          </a:solidFill>
+          <a:ln>
+            <a:noFill/>
+          </a:ln>
+        </p:spPr>
+        <p:style>
+          <a:lnRef idx="1">
+            <a:schemeClr val="accent1"/>
+          </a:lnRef>
+          <a:fillRef idx="3">
+            <a:schemeClr val="accent1"/>
+          </a:fillRef>
+          <a:effectRef idx="2">
+            <a:schemeClr val="accent1"/>
+          </a:effectRef>
+          <a:fontRef idx="minor">
+            <a:schemeClr val="lt1"/>
+          </a:fontRef>
+        </p:style>
+        <p:txBody>
+          <a:bodyPr rtlCol="0" anchor="ctr"/>
+          <a:lstStyle/>
+          <a:p>
+            <a:pPr algn="ctr"/>
+          </a:p>
+        </p:txBody>
+      </p:sp>
+      <p:sp>
+        <p:nvSpPr>
+          <p:cNvPr id="35" name="Rounded Rectangle 34"/>
+          <p:cNvSpPr/>
+          <p:nvPr/>
+        </p:nvSpPr>
+        <p:spPr>
+          <a:xfrm>
+            <a:off x="7315200" y="3703320"/>
+            <a:ext cx="1371600" cy="731520"/>
+          </a:xfrm>
+          <a:prstGeom prst="roundRect">
+            <a:avLst/>
+          </a:prstGeom>
+          <a:solidFill>
+            <a:srgbClr val="8B5CF6"/>
+          </a:solidFill>
+          <a:ln>
+            <a:noFill/>
+          </a:ln>
+        </p:spPr>
+        <p:style>
+          <a:lnRef idx="1">
+            <a:schemeClr val="accent1"/>
+          </a:lnRef>
+          <a:fillRef idx="3">
+            <a:schemeClr val="accent1"/>
+          </a:fillRef>
+          <a:effectRef idx="2">
+            <a:schemeClr val="accent1"/>
+          </a:effectRef>
+          <a:fontRef idx="minor">
+            <a:schemeClr val="lt1"/>
+          </a:fontRef>
+        </p:style>
+        <p:txBody>
+          <a:bodyPr rtlCol="0" anchor="ctr" wrap="square" tIns="0" bIns="0"/>
+          <a:lstStyle/>
+          <a:p>
+            <a:pPr algn="ctr">
+              <a:defRPr sz="900" b="1">
+                <a:solidFill>
+                  <a:srgbClr val="FFFFFF"/>
+                </a:solidFill>
+              </a:defRPr>
+            </a:pPr>
+            <a:r>
+              <a:t>Convert</a:t>
+            </a:r>
+            <a:br/>
+            <a:r>
+              <a:t>Modal</a:t>
+            </a:r>
+          </a:p>
+        </p:txBody>
+      </p:sp>
+      <p:sp>
+        <p:nvSpPr>
+          <p:cNvPr id="36" name="TextBox 35"/>
+          <p:cNvSpPr txBox="1"/>
+          <p:nvPr/>
+        </p:nvSpPr>
+        <p:spPr>
+          <a:xfrm>
+            <a:off x="7315200" y="4480560"/>
+            <a:ext cx="1371600" cy="457200"/>
+          </a:xfrm>
+          <a:prstGeom prst="rect">
+            <a:avLst/>
+          </a:prstGeom>
+          <a:noFill/>
+        </p:spPr>
+        <p:txBody>
+          <a:bodyPr wrap="square">
+            <a:spAutoFit/>
+          </a:bodyPr>
+          <a:lstStyle/>
+          <a:p>
+            <a:pPr algn="ctr">
+              <a:defRPr sz="800">
+                <a:solidFill>
+                  <a:srgbClr val="64748B"/>
+                </a:solidFill>
+              </a:defRPr>
+            </a:pPr>
+            <a:r>
+              <a:t>Requirement (linked)</a:t>
+            </a:r>
+            <a:br/>
+            <a:r>
+              <a:t>or Backlog (unlinked)</a:t>
+            </a:r>
+          </a:p>
+        </p:txBody>
+      </p:sp>
+      <p:sp>
+        <p:nvSpPr>
+          <p:cNvPr id="37" name="Rounded Rectangle 36"/>
+          <p:cNvSpPr/>
+          <p:nvPr/>
+        </p:nvSpPr>
+        <p:spPr>
+          <a:xfrm>
+            <a:off x="457200" y="4572000"/>
+            <a:ext cx="640080" cy="228600"/>
+          </a:xfrm>
+          <a:prstGeom prst="roundRect">
+            <a:avLst/>
+          </a:prstGeom>
+          <a:solidFill>
+            <a:srgbClr val="6366F1"/>
+          </a:solidFill>
+          <a:ln>
+            <a:noFill/>
+          </a:ln>
+        </p:spPr>
+        <p:style>
+          <a:lnRef idx="1">
+            <a:schemeClr val="accent1"/>
+          </a:lnRef>
+          <a:fillRef idx="3">
+            <a:schemeClr val="accent1"/>
+          </a:fillRef>
+          <a:effectRef idx="2">
+            <a:schemeClr val="accent1"/>
+          </a:effectRef>
+          <a:fontRef idx="minor">
+            <a:schemeClr val="lt1"/>
+          </a:fontRef>
+        </p:style>
+        <p:txBody>
+          <a:bodyPr rtlCol="0" anchor="ctr" wrap="square" tIns="0" bIns="0"/>
+          <a:lstStyle/>
+          <a:p>
+            <a:pPr algn="ctr">
+              <a:defRPr sz="800" b="1">
+                <a:solidFill>
+                  <a:srgbClr val="FFFFFF"/>
+                </a:solidFill>
+              </a:defRPr>
+            </a:pPr>
+            <a:r>
+              <a:t>Flow Step</a:t>
+            </a:r>
+          </a:p>
+        </p:txBody>
+      </p:sp>
+      <p:sp>
+        <p:nvSpPr>
+          <p:cNvPr id="38" name="Rounded Rectangle 37"/>
+          <p:cNvSpPr/>
+          <p:nvPr/>
+        </p:nvSpPr>
+        <p:spPr>
+          <a:xfrm>
+            <a:off x="1234440" y="4572000"/>
+            <a:ext cx="640080" cy="228600"/>
+          </a:xfrm>
+          <a:prstGeom prst="roundRect">
+            <a:avLst/>
+          </a:prstGeom>
+          <a:solidFill>
+            <a:srgbClr val="22C55E"/>
+          </a:solidFill>
+          <a:ln>
+            <a:noFill/>
+          </a:ln>
+        </p:spPr>
+        <p:style>
+          <a:lnRef idx="1">
+            <a:schemeClr val="accent1"/>
+          </a:lnRef>
+          <a:fillRef idx="3">
+            <a:schemeClr val="accent1"/>
+          </a:fillRef>
+          <a:effectRef idx="2">
+            <a:schemeClr val="accent1"/>
+          </a:effectRef>
+          <a:fontRef idx="minor">
+            <a:schemeClr val="lt1"/>
+          </a:fontRef>
+        </p:style>
+        <p:txBody>
+          <a:bodyPr rtlCol="0" anchor="ctr" wrap="square" tIns="0" bIns="0"/>
+          <a:lstStyle/>
+          <a:p>
+            <a:pPr algn="ctr">
+              <a:defRPr sz="800" b="1">
+                <a:solidFill>
+                  <a:srgbClr val="FFFFFF"/>
+                </a:solidFill>
+              </a:defRPr>
+            </a:pPr>
+            <a:r>
+              <a:t>Approve</a:t>
+            </a:r>
+          </a:p>
+        </p:txBody>
+      </p:sp>
+      <p:sp>
+        <p:nvSpPr>
+          <p:cNvPr id="39" name="Rounded Rectangle 38"/>
+          <p:cNvSpPr/>
+          <p:nvPr/>
+        </p:nvSpPr>
+        <p:spPr>
+          <a:xfrm>
+            <a:off x="2011680" y="4572000"/>
+            <a:ext cx="640080" cy="228600"/>
+          </a:xfrm>
+          <a:prstGeom prst="roundRect">
+            <a:avLst/>
+          </a:prstGeom>
+          <a:solidFill>
+            <a:srgbClr val="EAB308"/>
+          </a:solidFill>
+          <a:ln>
+            <a:noFill/>
+          </a:ln>
+        </p:spPr>
+        <p:style>
+          <a:lnRef idx="1">
+            <a:schemeClr val="accent1"/>
+          </a:lnRef>
+          <a:fillRef idx="3">
+            <a:schemeClr val="accent1"/>
+          </a:fillRef>
+          <a:effectRef idx="2">
+            <a:schemeClr val="accent1"/>
+          </a:effectRef>
+          <a:fontRef idx="minor">
+            <a:schemeClr val="lt1"/>
+          </a:fontRef>
+        </p:style>
+        <p:txBody>
+          <a:bodyPr rtlCol="0" anchor="ctr" wrap="square" tIns="0" bIns="0"/>
+          <a:lstStyle/>
+          <a:p>
+            <a:pPr algn="ctr">
+              <a:defRPr sz="800" b="1">
+                <a:solidFill>
+                  <a:srgbClr val="FFFFFF"/>
+                </a:solidFill>
+              </a:defRPr>
+            </a:pPr>
+            <a:r>
+              <a:t>Backlog</a:t>
+            </a:r>
+          </a:p>
+        </p:txBody>
+      </p:sp>
+      <p:sp>
+        <p:nvSpPr>
+          <p:cNvPr id="40" name="Rounded Rectangle 39"/>
+          <p:cNvSpPr/>
+          <p:nvPr/>
+        </p:nvSpPr>
+        <p:spPr>
+          <a:xfrm>
+            <a:off x="2788920" y="4572000"/>
+            <a:ext cx="640080" cy="228600"/>
+          </a:xfrm>
+          <a:prstGeom prst="roundRect">
+            <a:avLst/>
+          </a:prstGeom>
+          <a:solidFill>
+            <a:srgbClr val="EF4444"/>
+          </a:solidFill>
+          <a:ln>
+            <a:noFill/>
+          </a:ln>
+        </p:spPr>
+        <p:style>
+          <a:lnRef idx="1">
+            <a:schemeClr val="accent1"/>
+          </a:lnRef>
+          <a:fillRef idx="3">
+            <a:schemeClr val="accent1"/>
+          </a:fillRef>
+          <a:effectRef idx="2">
+            <a:schemeClr val="accent1"/>
+          </a:effectRef>
+          <a:fontRef idx="minor">
+            <a:schemeClr val="lt1"/>
+          </a:fontRef>
+        </p:style>
+        <p:txBody>
+          <a:bodyPr rtlCol="0" anchor="ctr" wrap="square" tIns="0" bIns="0"/>
+          <a:lstStyle/>
+          <a:p>
+            <a:pPr algn="ctr">
+              <a:defRPr sz="800" b="1">
+                <a:solidFill>
+                  <a:srgbClr val="FFFFFF"/>
+                </a:solidFill>
+              </a:defRPr>
+            </a:pPr>
+            <a:r>
+              <a:t>Reject</a:t>
+            </a:r>
+          </a:p>
+        </p:txBody>
+      </p:sp>
+      <p:sp>
+        <p:nvSpPr>
+          <p:cNvPr id="41" name="Rounded Rectangle 40"/>
+          <p:cNvSpPr/>
+          <p:nvPr/>
+        </p:nvSpPr>
+        <p:spPr>
+          <a:xfrm>
+            <a:off x="3566160" y="4572000"/>
+            <a:ext cx="640080" cy="228600"/>
+          </a:xfrm>
+          <a:prstGeom prst="roundRect">
+            <a:avLst/>
+          </a:prstGeom>
+          <a:solidFill>
+            <a:srgbClr val="8B5CF6"/>
+          </a:solidFill>
+          <a:ln>
+            <a:noFill/>
+          </a:ln>
+        </p:spPr>
+        <p:style>
+          <a:lnRef idx="1">
+            <a:schemeClr val="accent1"/>
+          </a:lnRef>
+          <a:fillRef idx="3">
+            <a:schemeClr val="accent1"/>
+          </a:fillRef>
+          <a:effectRef idx="2">
+            <a:schemeClr val="accent1"/>
+          </a:effectRef>
+          <a:fontRef idx="minor">
+            <a:schemeClr val="lt1"/>
+          </a:fontRef>
+        </p:style>
+        <p:txBody>
+          <a:bodyPr rtlCol="0" anchor="ctr" wrap="square" tIns="0" bIns="0"/>
+          <a:lstStyle/>
+          <a:p>
+            <a:pPr algn="ctr">
+              <a:defRPr sz="800" b="1">
+                <a:solidFill>
+                  <a:srgbClr val="FFFFFF"/>
+                </a:solidFill>
+              </a:defRPr>
+            </a:pPr>
+            <a:r>
+              <a:t>Convert</a:t>
+            </a:r>
+          </a:p>
+        </p:txBody>
+      </p:sp>
+      <p:sp>
+        <p:nvSpPr>
+          <p:cNvPr id="42" name="TextBox 41"/>
+          <p:cNvSpPr txBox="1"/>
+          <p:nvPr/>
+        </p:nvSpPr>
+        <p:spPr>
+          <a:xfrm>
+            <a:off x="457200" y="4892040"/>
+            <a:ext cx="10058400" cy="731520"/>
           </a:xfrm>
           <a:prstGeom prst="rect">
             <a:avLst/>
@@ -5647,74 +7347,31 @@
           <a:p>
             <a:pPr>
               <a:lnSpc>
-                <a:spcPts val="1900"/>
+                <a:spcPts val="1600"/>
               </a:lnSpc>
-              <a:defRPr sz="1300">
-                <a:solidFill>
-                  <a:srgbClr val="0F172A"/>
-                </a:solidFill>
-              </a:defRPr>
-            </a:pPr>
-            <a:r>
-              <a:t>PURPOSE: Define and manage business capabilities that link</a:t>
-            </a:r>
-            <a:br/>
-            <a:r>
-              <a:t>products, demands, and requirements together.</a:t>
-            </a:r>
-            <a:br/>
-            <a:br/>
-            <a:r>
-              <a:t>FEATURES:</a:t>
-            </a:r>
-            <a:br/>
-            <a:r>
-              <a:t>• Create/Edit/Delete capabilities</a:t>
-            </a:r>
-            <a:br/>
-            <a:r>
-              <a:t>• Each capability has: Name, Description, Type, Cost</a:t>
-            </a:r>
-            <a:br/>
-            <a:r>
-              <a:t>• Capability Type sourced from config (capability_type)</a:t>
-            </a:r>
-            <a:br/>
-            <a:r>
-              <a:t>• Capability-Product links via linking table</a:t>
-            </a:r>
-            <a:br/>
-            <a:r>
-              <a:t>   (one capability can serve multiple products)</a:t>
-            </a:r>
-            <a:br/>
-            <a:br/>
-            <a:r>
-              <a:t>USAGE IN WORKFLOW:</a:t>
-            </a:r>
-            <a:br/>
-            <a:r>
-              <a:t>• Demands reference a capability</a:t>
-            </a:r>
-            <a:br/>
-            <a:r>
-              <a:t>• Requirements reference a capability</a:t>
-            </a:r>
-            <a:br/>
-            <a:r>
-              <a:t>• Capabilities bridge business needs to product delivery</a:t>
-            </a:r>
-            <a:br/>
-            <a:br/>
-            <a:r>
-              <a:t>ACCESS: Admin, VSPMO, VSO, DL, BA (5 roles)</a:t>
-            </a:r>
-          </a:p>
-        </p:txBody>
-      </p:sp>
-      <p:sp>
-        <p:nvSpPr>
-          <p:cNvPr id="6" name="TextBox 5"/>
+              <a:defRPr sz="1000">
+                <a:solidFill>
+                  <a:srgbClr val="64748B"/>
+                </a:solidFill>
+              </a:defRPr>
+            </a:pPr>
+            <a:r>
+              <a:t>💡 At intermediate steps: only flow progression options shown.</a:t>
+            </a:r>
+            <a:br/>
+            <a:r>
+              <a:t>At the FINAL step: terminal actions appear (Approved / Backlog / Reject).</a:t>
+            </a:r>
+            <a:br/>
+            <a:r>
+              <a:t>Convert creates a Requirement (linked to project) or Backlog item (unlinked).</a:t>
+            </a:r>
+          </a:p>
+        </p:txBody>
+      </p:sp>
+      <p:sp>
+        <p:nvSpPr>
+          <p:cNvPr id="43" name="TextBox 42"/>
           <p:cNvSpPr txBox="1"/>
           <p:nvPr/>
         </p:nvSpPr>
@@ -5742,14 +7399,14 @@
               </a:defRPr>
             </a:pPr>
             <a:r>
-              <a:t>17/33</a:t>
-            </a:r>
-          </a:p>
-        </p:txBody>
-      </p:sp>
-      <p:sp>
-        <p:nvSpPr>
-          <p:cNvPr id="7" name="TextBox 6"/>
+              <a:t>17/34</a:t>
+            </a:r>
+          </a:p>
+        </p:txBody>
+      </p:sp>
+      <p:sp>
+        <p:nvSpPr>
+          <p:cNvPr id="44" name="TextBox 43"/>
           <p:cNvSpPr txBox="1"/>
           <p:nvPr/>
         </p:nvSpPr>
@@ -5881,7 +7538,7 @@
               </a:defRPr>
             </a:pPr>
             <a:r>
-              <a:t>📦 Products</a:t>
+              <a:t>🎯 Capabilities</a:t>
             </a:r>
           </a:p>
         </p:txBody>
@@ -5916,7 +7573,7 @@
               </a:defRPr>
             </a:pPr>
             <a:r>
-              <a:t>Application catalog linked to Value Streams</a:t>
+              <a:t>Business capability catalog</a:t>
             </a:r>
           </a:p>
         </p:txBody>
@@ -5954,7 +7611,11 @@
               </a:defRPr>
             </a:pPr>
             <a:r>
-              <a:t>PURPOSE: Manage the product/application portfolio.</a:t>
+              <a:t>PURPOSE: Define and manage business capabilities that link</a:t>
+            </a:r>
+            <a:br/>
+            <a:r>
+              <a:t>products, demands, and requirements together.</a:t>
             </a:r>
             <a:br/>
             <a:br/>
@@ -5963,45 +7624,45 @@
             </a:r>
             <a:br/>
             <a:r>
-              <a:t>• Create/Edit/Delete products</a:t>
-            </a:r>
-            <a:br/>
-            <a:r>
-              <a:t>• Each product has: Name, Short Name, Journey Name</a:t>
-            </a:r>
-            <a:br/>
-            <a:r>
-              <a:t>• Linked to a Value Stream (drives governance template)</a:t>
-            </a:r>
-            <a:br/>
-            <a:r>
-              <a:t>• Governance Status and Contact fields</a:t>
-            </a:r>
-            <a:br/>
-            <a:r>
-              <a:t>• Capability-Product links (assign capabilities to products)</a:t>
-            </a:r>
-            <a:br/>
-            <a:br/>
-            <a:r>
-              <a:t>RELATIONSHIPS:</a:t>
-            </a:r>
-            <a:br/>
-            <a:r>
-              <a:t>• Products are the target of Demands (pm_product)</a:t>
-            </a:r>
-            <a:br/>
-            <a:r>
-              <a:t>• Projects are linked to products (pm_productname)</a:t>
-            </a:r>
-            <a:br/>
-            <a:r>
-              <a:t>• Governance templates auto-detect from product's VS</a:t>
-            </a:r>
-            <a:br/>
-            <a:br/>
-            <a:r>
-              <a:t>ACCESS: All 8 roles (editing limited by role permissions)</a:t>
+              <a:t>• Create/Edit/Delete capabilities</a:t>
+            </a:r>
+            <a:br/>
+            <a:r>
+              <a:t>• Each capability has: Name, Description, Type, Cost</a:t>
+            </a:r>
+            <a:br/>
+            <a:r>
+              <a:t>• Capability Type sourced from config (capability_type)</a:t>
+            </a:r>
+            <a:br/>
+            <a:r>
+              <a:t>• Capability-Product links via linking table</a:t>
+            </a:r>
+            <a:br/>
+            <a:r>
+              <a:t>   (one capability can serve multiple products)</a:t>
+            </a:r>
+            <a:br/>
+            <a:br/>
+            <a:r>
+              <a:t>USAGE IN WORKFLOW:</a:t>
+            </a:r>
+            <a:br/>
+            <a:r>
+              <a:t>• Demands reference a capability</a:t>
+            </a:r>
+            <a:br/>
+            <a:r>
+              <a:t>• Requirements reference a capability</a:t>
+            </a:r>
+            <a:br/>
+            <a:r>
+              <a:t>• Capabilities bridge business needs to product delivery</a:t>
+            </a:r>
+            <a:br/>
+            <a:br/>
+            <a:r>
+              <a:t>ACCESS: Admin, VSPMO, VSO, DL, BA (5 roles)</a:t>
             </a:r>
           </a:p>
         </p:txBody>
@@ -6036,7 +7697,7 @@
               </a:defRPr>
             </a:pPr>
             <a:r>
-              <a:t>18/33</a:t>
+              <a:t>18/34</a:t>
             </a:r>
           </a:p>
         </p:txBody>
@@ -6175,7 +7836,7 @@
               </a:defRPr>
             </a:pPr>
             <a:r>
-              <a:t>📁 Projects</a:t>
+              <a:t>📦 Products</a:t>
             </a:r>
           </a:p>
         </p:txBody>
@@ -6210,7 +7871,7 @@
               </a:defRPr>
             </a:pPr>
             <a:r>
-              <a:t>Pipeline tracking with lock/unlock and governance</a:t>
+              <a:t>Application catalog linked to Value Streams</a:t>
             </a:r>
           </a:p>
         </p:txBody>
@@ -6248,7 +7909,7 @@
               </a:defRPr>
             </a:pPr>
             <a:r>
-              <a:t>PURPOSE: Manage delivery projects with pipeline status and scope control.</a:t>
+              <a:t>PURPOSE: Manage the product/application portfolio.</a:t>
             </a:r>
             <a:br/>
             <a:br/>
@@ -6257,45 +7918,45 @@
             </a:r>
             <a:br/>
             <a:r>
-              <a:t>• Create/Edit/Delete projects</a:t>
-            </a:r>
-            <a:br/>
-            <a:r>
-              <a:t>• Pipeline Board view (PipelineBoard component)</a:t>
-            </a:r>
-            <a:br/>
-            <a:r>
-              <a:t>• Each project has: Name, Product, Status, Completion %,</a:t>
-            </a:r>
-            <a:br/>
-            <a:r>
-              <a:t>  Enhancement Type, Priority, Scope, Year/Quarter</a:t>
-            </a:r>
-            <a:br/>
-            <a:r>
-              <a:t>• Gov Template override (auto-detect from VS or explicit)</a:t>
-            </a:r>
-            <a:br/>
-            <a:r>
-              <a:t>• 🔒 Lock/Unlock button (Admin/VSPMO/VSO only)</a:t>
-            </a:r>
-            <a:br/>
-            <a:r>
-              <a:t>   — Locked: no new requirements, no edits to existing ones</a:t>
-            </a:r>
-            <a:br/>
-            <a:r>
-              <a:t>   — Unlinked requirements can still be moved out (descope)</a:t>
-            </a:r>
-            <a:br/>
-            <a:br/>
-            <a:r>
-              <a:t>EXPAND ROW: Shows linked requirements with status badges</a:t>
-            </a:r>
-            <a:br/>
-            <a:br/>
-            <a:r>
-              <a:t>ACCESS: All 8 roles (lock/unlock restricted)</a:t>
+              <a:t>• Create/Edit/Delete products</a:t>
+            </a:r>
+            <a:br/>
+            <a:r>
+              <a:t>• Each product has: Name, Short Name, Journey Name</a:t>
+            </a:r>
+            <a:br/>
+            <a:r>
+              <a:t>• Linked to a Value Stream (drives governance template)</a:t>
+            </a:r>
+            <a:br/>
+            <a:r>
+              <a:t>• Governance Status and Contact fields</a:t>
+            </a:r>
+            <a:br/>
+            <a:r>
+              <a:t>• Capability-Product links (assign capabilities to products)</a:t>
+            </a:r>
+            <a:br/>
+            <a:br/>
+            <a:r>
+              <a:t>RELATIONSHIPS:</a:t>
+            </a:r>
+            <a:br/>
+            <a:r>
+              <a:t>• Products are the target of Demands (pm_product)</a:t>
+            </a:r>
+            <a:br/>
+            <a:r>
+              <a:t>• Projects are linked to products (pm_productname)</a:t>
+            </a:r>
+            <a:br/>
+            <a:r>
+              <a:t>• Governance templates auto-detect from product's VS</a:t>
+            </a:r>
+            <a:br/>
+            <a:br/>
+            <a:r>
+              <a:t>ACCESS: All 8 roles (editing limited by role permissions)</a:t>
             </a:r>
           </a:p>
         </p:txBody>
@@ -6330,7 +7991,7 @@
               </a:defRPr>
             </a:pPr>
             <a:r>
-              <a:t>19/33</a:t>
+              <a:t>19/34</a:t>
             </a:r>
           </a:p>
         </p:txBody>
@@ -6575,7 +8236,7 @@
               </a:defRPr>
             </a:pPr>
             <a:r>
-              <a:t>2/33</a:t>
+              <a:t>2/34</a:t>
             </a:r>
           </a:p>
         </p:txBody>
@@ -6714,7 +8375,7 @@
               </a:defRPr>
             </a:pPr>
             <a:r>
-              <a:t>📋 Requirements (Backlog)</a:t>
+              <a:t>📁 Projects</a:t>
             </a:r>
           </a:p>
         </p:txBody>
@@ -6749,7 +8410,7 @@
               </a:defRPr>
             </a:pPr>
             <a:r>
-              <a:t>All/Linked/Backlog modes with priority and project linking</a:t>
+              <a:t>Pipeline tracking with lock/unlock and governance</a:t>
             </a:r>
           </a:p>
         </p:txBody>
@@ -6787,63 +8448,54 @@
               </a:defRPr>
             </a:pPr>
             <a:r>
-              <a:t>PURPOSE: Manage requirements — both unlinked (Backlog)</a:t>
-            </a:r>
-            <a:br/>
-            <a:r>
-              <a:t>and linked to projects (Requirements).</a:t>
-            </a:r>
-            <a:br/>
-            <a:br/>
-            <a:r>
-              <a:t>SAME TABLE: pm_requirement serves double duty:</a:t>
-            </a:r>
-            <a:br/>
-            <a:r>
-              <a:t>• No pm_projectname → Backlog (status: Prioritized)</a:t>
-            </a:r>
-            <a:br/>
-            <a:r>
-              <a:t>• Has pm_projectname → Requirement (status: Linked)</a:t>
-            </a:r>
-            <a:br/>
-            <a:br/>
-            <a:r>
-              <a:t>VIEW MODES: All | Linked | Backlog</a:t>
-            </a:r>
-            <a:br/>
-            <a:br/>
-            <a:r>
-              <a:t>ACTIONS:</a:t>
-            </a:r>
-            <a:br/>
-            <a:r>
-              <a:t>• Link to Project — dropdown on backlog items → sets project + Linked</a:t>
-            </a:r>
-            <a:br/>
-            <a:r>
-              <a:t>  (locked projects are hidden from the dropdown)</a:t>
-            </a:r>
-            <a:br/>
-            <a:r>
-              <a:t>• 📦 Backlog/Unlink — moves requirement back to backlog</a:t>
-            </a:r>
-            <a:br/>
-            <a:r>
-              <a:t>  (Admin/VSPMO/VSO only; works even on locked projects)</a:t>
-            </a:r>
-            <a:br/>
-            <a:r>
-              <a:t>• ✏️ Edit — inline modal (blocked if project is locked)</a:t>
-            </a:r>
-            <a:br/>
-            <a:r>
-              <a:t>• Priority column for backlog ranking</a:t>
-            </a:r>
-            <a:br/>
-            <a:br/>
-            <a:r>
-              <a:t>Expanded row shows linked epics and assignments</a:t>
+              <a:t>PURPOSE: Manage delivery projects with pipeline status and scope control.</a:t>
+            </a:r>
+            <a:br/>
+            <a:br/>
+            <a:r>
+              <a:t>FEATURES:</a:t>
+            </a:r>
+            <a:br/>
+            <a:r>
+              <a:t>• Create/Edit/Delete projects</a:t>
+            </a:r>
+            <a:br/>
+            <a:r>
+              <a:t>• Pipeline Board view (PipelineBoard component)</a:t>
+            </a:r>
+            <a:br/>
+            <a:r>
+              <a:t>• Each project has: Name, Product, Status, Completion %,</a:t>
+            </a:r>
+            <a:br/>
+            <a:r>
+              <a:t>  Enhancement Type, Priority, Scope, Year/Quarter</a:t>
+            </a:r>
+            <a:br/>
+            <a:r>
+              <a:t>• Gov Template override (auto-detect from VS or explicit)</a:t>
+            </a:r>
+            <a:br/>
+            <a:r>
+              <a:t>• 🔒 Lock/Unlock button (Admin/VSPMO/VSO only)</a:t>
+            </a:r>
+            <a:br/>
+            <a:r>
+              <a:t>   — Locked: no new requirements, no edits to existing ones</a:t>
+            </a:r>
+            <a:br/>
+            <a:r>
+              <a:t>   — Unlinked requirements can still be moved out (descope)</a:t>
+            </a:r>
+            <a:br/>
+            <a:br/>
+            <a:r>
+              <a:t>EXPAND ROW: Shows linked requirements with status badges</a:t>
+            </a:r>
+            <a:br/>
+            <a:br/>
+            <a:r>
+              <a:t>ACCESS: All 8 roles (lock/unlock restricted)</a:t>
             </a:r>
           </a:p>
         </p:txBody>
@@ -6878,7 +8530,7 @@
               </a:defRPr>
             </a:pPr>
             <a:r>
-              <a:t>20/33</a:t>
+              <a:t>20/34</a:t>
             </a:r>
           </a:p>
         </p:txBody>
@@ -7017,7 +8669,7 @@
               </a:defRPr>
             </a:pPr>
             <a:r>
-              <a:t>⚡ Epics</a:t>
+              <a:t>📋 Requirements (Backlog)</a:t>
             </a:r>
           </a:p>
         </p:txBody>
@@ -7052,7 +8704,7 @@
               </a:defRPr>
             </a:pPr>
             <a:r>
-              <a:t>Project breakdown with effort estimation and RAG status</a:t>
+              <a:t>All/Linked/Backlog modes with priority and project linking</a:t>
             </a:r>
           </a:p>
         </p:txBody>
@@ -7090,62 +8742,63 @@
               </a:defRPr>
             </a:pPr>
             <a:r>
-              <a:t>PURPOSE: Break down projects into manageable epics.</a:t>
-            </a:r>
-            <a:br/>
-            <a:br/>
-            <a:r>
-              <a:t>FEATURES:</a:t>
-            </a:r>
-            <a:br/>
-            <a:r>
-              <a:t>• Create/Edit/Delete epics</a:t>
-            </a:r>
-            <a:br/>
-            <a:r>
-              <a:t>• Each epic has: Title, Detail, Project link</a:t>
-            </a:r>
-            <a:br/>
-            <a:r>
-              <a:t>• Jira Link for external tracking</a:t>
-            </a:r>
-            <a:br/>
-            <a:r>
-              <a:t>• Estimated Effort (days)</a:t>
-            </a:r>
-            <a:br/>
-            <a:r>
-              <a:t>• Release Date, Start Date, Completed Date</a:t>
-            </a:r>
-            <a:br/>
-            <a:r>
-              <a:t>• RAG Status (G/A/R) for health tracking</a:t>
-            </a:r>
-            <a:br/>
-            <a:br/>
-            <a:r>
-              <a:t>RELATIONSHIPS:</a:t>
-            </a:r>
-            <a:br/>
-            <a:r>
-              <a:t>• Epics belong to a project</a:t>
-            </a:r>
-            <a:br/>
-            <a:r>
-              <a:t>• User Stories belong to an epic</a:t>
-            </a:r>
-            <a:br/>
-            <a:r>
-              <a:t>• Resource Assignments target epics</a:t>
-            </a:r>
-            <a:br/>
-            <a:r>
-              <a:t>  (team membership derived from assignment→resource→team)</a:t>
-            </a:r>
-            <a:br/>
-            <a:br/>
-            <a:r>
-              <a:t>ACCESS: All roles (except RM/ITSO cannot edit)</a:t>
+              <a:t>PURPOSE: Manage requirements — both unlinked (Backlog)</a:t>
+            </a:r>
+            <a:br/>
+            <a:r>
+              <a:t>and linked to projects (Requirements).</a:t>
+            </a:r>
+            <a:br/>
+            <a:br/>
+            <a:r>
+              <a:t>SAME TABLE: pm_requirement serves double duty:</a:t>
+            </a:r>
+            <a:br/>
+            <a:r>
+              <a:t>• No pm_projectname → Backlog (status: Prioritized)</a:t>
+            </a:r>
+            <a:br/>
+            <a:r>
+              <a:t>• Has pm_projectname → Requirement (status: Linked)</a:t>
+            </a:r>
+            <a:br/>
+            <a:br/>
+            <a:r>
+              <a:t>VIEW MODES: All | Linked | Backlog</a:t>
+            </a:r>
+            <a:br/>
+            <a:br/>
+            <a:r>
+              <a:t>ACTIONS:</a:t>
+            </a:r>
+            <a:br/>
+            <a:r>
+              <a:t>• Link to Project — dropdown on backlog items → sets project + Linked</a:t>
+            </a:r>
+            <a:br/>
+            <a:r>
+              <a:t>  (locked projects are hidden from the dropdown)</a:t>
+            </a:r>
+            <a:br/>
+            <a:r>
+              <a:t>• 📦 Backlog/Unlink — moves requirement back to backlog</a:t>
+            </a:r>
+            <a:br/>
+            <a:r>
+              <a:t>  (Admin/VSPMO/VSO only; works even on locked projects)</a:t>
+            </a:r>
+            <a:br/>
+            <a:r>
+              <a:t>• ✏️ Edit — inline modal (blocked if project is locked)</a:t>
+            </a:r>
+            <a:br/>
+            <a:r>
+              <a:t>• Priority column for backlog ranking</a:t>
+            </a:r>
+            <a:br/>
+            <a:br/>
+            <a:r>
+              <a:t>Expanded row shows linked epics and assignments</a:t>
             </a:r>
           </a:p>
         </p:txBody>
@@ -7180,7 +8833,7 @@
               </a:defRPr>
             </a:pPr>
             <a:r>
-              <a:t>21/33</a:t>
+              <a:t>21/34</a:t>
             </a:r>
           </a:p>
         </p:txBody>
@@ -7319,7 +8972,7 @@
               </a:defRPr>
             </a:pPr>
             <a:r>
-              <a:t>📝 User Stories</a:t>
+              <a:t>⚡ Epics</a:t>
             </a:r>
           </a:p>
         </p:txBody>
@@ -7354,7 +9007,7 @@
               </a:defRPr>
             </a:pPr>
             <a:r>
-              <a:t>Detailed requirements with acceptance criteria and story points</a:t>
+              <a:t>Project breakdown with effort estimation and RAG status</a:t>
             </a:r>
           </a:p>
         </p:txBody>
@@ -7392,7 +9045,7 @@
               </a:defRPr>
             </a:pPr>
             <a:r>
-              <a:t>PURPOSE: Detailed work items within epics.</a:t>
+              <a:t>PURPOSE: Break down projects into manageable epics.</a:t>
             </a:r>
             <a:br/>
             <a:br/>
@@ -7401,19 +9054,27 @@
             </a:r>
             <a:br/>
             <a:r>
-              <a:t>• Create/Edit/Delete user stories</a:t>
-            </a:r>
-            <a:br/>
-            <a:r>
-              <a:t>• Each story has: Detail, Epic link</a:t>
-            </a:r>
-            <a:br/>
-            <a:r>
-              <a:t>• Acceptance Criteria (UAC) — multi-line text</a:t>
-            </a:r>
-            <a:br/>
-            <a:r>
-              <a:t>• Story Points for estimation</a:t>
+              <a:t>• Create/Edit/Delete epics</a:t>
+            </a:r>
+            <a:br/>
+            <a:r>
+              <a:t>• Each epic has: Title, Detail, Project link</a:t>
+            </a:r>
+            <a:br/>
+            <a:r>
+              <a:t>• Jira Link for external tracking</a:t>
+            </a:r>
+            <a:br/>
+            <a:r>
+              <a:t>• Estimated Effort (days)</a:t>
+            </a:r>
+            <a:br/>
+            <a:r>
+              <a:t>• Release Date, Start Date, Completed Date</a:t>
+            </a:r>
+            <a:br/>
+            <a:r>
+              <a:t>• RAG Status (G/A/R) for health tracking</a:t>
             </a:r>
             <a:br/>
             <a:br/>
@@ -7422,33 +9083,24 @@
             </a:r>
             <a:br/>
             <a:r>
-              <a:t>• Stories link to epics (which link to projects)</a:t>
-            </a:r>
-            <a:br/>
-            <a:r>
-              <a:t>• Stories are registered into releases (via Release Items)</a:t>
-            </a:r>
-            <a:br/>
-            <a:r>
-              <a:t>• Sprint Board tracks story points per team×product</a:t>
-            </a:r>
-            <a:br/>
-            <a:br/>
-            <a:r>
-              <a:t>USAGE IN SPRINT BOARD:</a:t>
-            </a:r>
-            <a:br/>
-            <a:r>
-              <a:t>• Completed story points = progress tracking</a:t>
-            </a:r>
-            <a:br/>
-            <a:r>
-              <a:t>• Acceptance criteria shown in sprint cards (truncated)</a:t>
-            </a:r>
-            <a:br/>
-            <a:br/>
-            <a:r>
-              <a:t>ACCESS: All roles (edit restricted by role permissions)</a:t>
+              <a:t>• Epics belong to a project</a:t>
+            </a:r>
+            <a:br/>
+            <a:r>
+              <a:t>• User Stories belong to an epic</a:t>
+            </a:r>
+            <a:br/>
+            <a:r>
+              <a:t>• Resource Assignments target epics</a:t>
+            </a:r>
+            <a:br/>
+            <a:r>
+              <a:t>  (team membership derived from assignment→resource→team)</a:t>
+            </a:r>
+            <a:br/>
+            <a:br/>
+            <a:r>
+              <a:t>ACCESS: All roles (except RM/ITSO cannot edit)</a:t>
             </a:r>
           </a:p>
         </p:txBody>
@@ -7483,7 +9135,7 @@
               </a:defRPr>
             </a:pPr>
             <a:r>
-              <a:t>22/33</a:t>
+              <a:t>22/34</a:t>
             </a:r>
           </a:p>
         </p:txBody>
@@ -7622,7 +9274,7 @@
               </a:defRPr>
             </a:pPr>
             <a:r>
-              <a:t>⚠️ Risks</a:t>
+              <a:t>📝 User Stories</a:t>
             </a:r>
           </a:p>
         </p:txBody>
@@ -7657,7 +9309,7 @@
               </a:defRPr>
             </a:pPr>
             <a:r>
-              <a:t>Track risks linked to products and requirements</a:t>
+              <a:t>Detailed requirements with acceptance criteria and story points</a:t>
             </a:r>
           </a:p>
         </p:txBody>
@@ -7695,7 +9347,7 @@
               </a:defRPr>
             </a:pPr>
             <a:r>
-              <a:t>PURPOSE: Identify and monitor project risks.</a:t>
+              <a:t>PURPOSE: Detailed work items within epics.</a:t>
             </a:r>
             <a:br/>
             <a:br/>
@@ -7704,32 +9356,49 @@
             </a:r>
             <a:br/>
             <a:r>
-              <a:t>• Create/Edit/Delete risks</a:t>
-            </a:r>
-            <a:br/>
-            <a:r>
-              <a:t>• Each risk has: Summary, Detail</a:t>
-            </a:r>
-            <a:br/>
-            <a:r>
-              <a:t>• Linked to a Product</a:t>
-            </a:r>
-            <a:br/>
-            <a:r>
-              <a:t>• Optionally linked to a Requirement</a:t>
-            </a:r>
-            <a:br/>
-            <a:br/>
-            <a:r>
-              <a:t>DASHBOARD INTEGRATION:</a:t>
-            </a:r>
-            <a:br/>
-            <a:r>
-              <a:t>• Risk counts shown on Portfolio product cards</a:t>
-            </a:r>
-            <a:br/>
-            <a:r>
-              <a:t>• Project rows show risk count in Related column</a:t>
+              <a:t>• Create/Edit/Delete user stories</a:t>
+            </a:r>
+            <a:br/>
+            <a:r>
+              <a:t>• Each story has: Detail, Epic link</a:t>
+            </a:r>
+            <a:br/>
+            <a:r>
+              <a:t>• Acceptance Criteria (UAC) — multi-line text</a:t>
+            </a:r>
+            <a:br/>
+            <a:r>
+              <a:t>• Story Points for estimation</a:t>
+            </a:r>
+            <a:br/>
+            <a:br/>
+            <a:r>
+              <a:t>RELATIONSHIPS:</a:t>
+            </a:r>
+            <a:br/>
+            <a:r>
+              <a:t>• Stories link to epics (which link to projects)</a:t>
+            </a:r>
+            <a:br/>
+            <a:r>
+              <a:t>• Stories are registered into releases (via Release Items)</a:t>
+            </a:r>
+            <a:br/>
+            <a:r>
+              <a:t>• Sprint Board tracks story points per team×product</a:t>
+            </a:r>
+            <a:br/>
+            <a:br/>
+            <a:r>
+              <a:t>USAGE IN SPRINT BOARD:</a:t>
+            </a:r>
+            <a:br/>
+            <a:r>
+              <a:t>• Completed story points = progress tracking</a:t>
+            </a:r>
+            <a:br/>
+            <a:r>
+              <a:t>• Acceptance criteria shown in sprint cards (truncated)</a:t>
             </a:r>
             <a:br/>
             <a:br/>
@@ -7769,7 +9438,7 @@
               </a:defRPr>
             </a:pPr>
             <a:r>
-              <a:t>23/33</a:t>
+              <a:t>23/34</a:t>
             </a:r>
           </a:p>
         </p:txBody>
@@ -7908,7 +9577,7 @@
               </a:defRPr>
             </a:pPr>
             <a:r>
-              <a:t>🔗 Dependencies</a:t>
+              <a:t>⚠️ Risks</a:t>
             </a:r>
           </a:p>
         </p:txBody>
@@ -7943,7 +9612,7 @@
               </a:defRPr>
             </a:pPr>
             <a:r>
-              <a:t>Cross-product dependency tracking</a:t>
+              <a:t>Track risks linked to products and requirements</a:t>
             </a:r>
           </a:p>
         </p:txBody>
@@ -7981,7 +9650,7 @@
               </a:defRPr>
             </a:pPr>
             <a:r>
-              <a:t>PURPOSE: Track dependencies between products and requirements.</a:t>
+              <a:t>PURPOSE: Identify and monitor project risks.</a:t>
             </a:r>
             <a:br/>
             <a:br/>
@@ -7990,11 +9659,11 @@
             </a:r>
             <a:br/>
             <a:r>
-              <a:t>• Create/Edit/Delete dependencies</a:t>
-            </a:r>
-            <a:br/>
-            <a:r>
-              <a:t>• Each dependency has: Summary, Detail</a:t>
+              <a:t>• Create/Edit/Delete risks</a:t>
+            </a:r>
+            <a:br/>
+            <a:r>
+              <a:t>• Each risk has: Summary, Detail</a:t>
             </a:r>
             <a:br/>
             <a:r>
@@ -8011,11 +9680,11 @@
             </a:r>
             <a:br/>
             <a:r>
-              <a:t>• Dependency counts shown on Portfolio product cards</a:t>
-            </a:r>
-            <a:br/>
-            <a:r>
-              <a:t>• Helps identify cross-team blockers</a:t>
+              <a:t>• Risk counts shown on Portfolio product cards</a:t>
+            </a:r>
+            <a:br/>
+            <a:r>
+              <a:t>• Project rows show risk count in Related column</a:t>
             </a:r>
             <a:br/>
             <a:br/>
@@ -8055,7 +9724,7 @@
               </a:defRPr>
             </a:pPr>
             <a:r>
-              <a:t>24/33</a:t>
+              <a:t>24/34</a:t>
             </a:r>
           </a:p>
         </p:txBody>
@@ -8194,7 +9863,7 @@
               </a:defRPr>
             </a:pPr>
             <a:r>
-              <a:t>🚀 Release Management</a:t>
+              <a:t>🔗 Dependencies</a:t>
             </a:r>
           </a:p>
         </p:txBody>
@@ -8229,7 +9898,7 @@
               </a:defRPr>
             </a:pPr>
             <a:r>
-              <a:t>Epic-grouped with signoff workflow</a:t>
+              <a:t>Cross-product dependency tracking</a:t>
             </a:r>
           </a:p>
         </p:txBody>
@@ -8267,60 +9936,46 @@
               </a:defRPr>
             </a:pPr>
             <a:r>
-              <a:t>PURPOSE: Manage the release lifecycle from draft to released.</a:t>
-            </a:r>
-            <a:br/>
-            <a:br/>
-            <a:r>
-              <a:t>LIFECYCLE: Draft → Open → In Review → Released</a:t>
-            </a:r>
-            <a:br/>
-            <a:r>
-              <a:t>  (workflow buttons appear based on current status)</a:t>
-            </a:r>
-            <a:br/>
-            <a:br/>
-            <a:r>
-              <a:t>REGISTERING STORIES:</a:t>
-            </a:r>
-            <a:br/>
-            <a:r>
-              <a:t>• Click ➕ Register on an Open release</a:t>
-            </a:r>
-            <a:br/>
-            <a:r>
-              <a:t>• Select unregistered user stories (grouped by epic)</a:t>
-            </a:r>
-            <a:br/>
-            <a:r>
-              <a:t>• Two-level expand: Release → Epics → Stories</a:t>
-            </a:r>
-            <a:br/>
-            <a:br/>
-            <a:r>
-              <a:t>SIGNOFF WORKFLOW:</a:t>
-            </a:r>
-            <a:br/>
-            <a:r>
-              <a:t>• Individual story signoff: Pending → Approved / Rejected</a:t>
-            </a:r>
-            <a:br/>
-            <a:r>
-              <a:t>• ✍️ Signoff modal: Decision + Note</a:t>
-            </a:r>
-            <a:br/>
-            <a:r>
-              <a:t>• Signoff recorded with by/date metadata</a:t>
-            </a:r>
-            <a:br/>
-            <a:br/>
-            <a:r>
-              <a:t>Click any row → expands epics → expands stories</a:t>
-            </a:r>
-            <a:br/>
-            <a:br/>
-            <a:r>
-              <a:t>ACCESS: All roles (edit restricted)</a:t>
+              <a:t>PURPOSE: Track dependencies between products and requirements.</a:t>
+            </a:r>
+            <a:br/>
+            <a:br/>
+            <a:r>
+              <a:t>FEATURES:</a:t>
+            </a:r>
+            <a:br/>
+            <a:r>
+              <a:t>• Create/Edit/Delete dependencies</a:t>
+            </a:r>
+            <a:br/>
+            <a:r>
+              <a:t>• Each dependency has: Summary, Detail</a:t>
+            </a:r>
+            <a:br/>
+            <a:r>
+              <a:t>• Linked to a Product</a:t>
+            </a:r>
+            <a:br/>
+            <a:r>
+              <a:t>• Optionally linked to a Requirement</a:t>
+            </a:r>
+            <a:br/>
+            <a:br/>
+            <a:r>
+              <a:t>DASHBOARD INTEGRATION:</a:t>
+            </a:r>
+            <a:br/>
+            <a:r>
+              <a:t>• Dependency counts shown on Portfolio product cards</a:t>
+            </a:r>
+            <a:br/>
+            <a:r>
+              <a:t>• Helps identify cross-team blockers</a:t>
+            </a:r>
+            <a:br/>
+            <a:br/>
+            <a:r>
+              <a:t>ACCESS: All roles (edit restricted by role permissions)</a:t>
             </a:r>
           </a:p>
         </p:txBody>
@@ -8355,7 +10010,7 @@
               </a:defRPr>
             </a:pPr>
             <a:r>
-              <a:t>25/33</a:t>
+              <a:t>25/34</a:t>
             </a:r>
           </a:p>
         </p:txBody>
@@ -8494,7 +10149,7 @@
               </a:defRPr>
             </a:pPr>
             <a:r>
-              <a:t>📋 Sprint Board</a:t>
+              <a:t>🚀 Release Management</a:t>
             </a:r>
           </a:p>
         </p:txBody>
@@ -8529,7 +10184,7 @@
               </a:defRPr>
             </a:pPr>
             <a:r>
-              <a:t>Team × Product matrix with SP tracking</a:t>
+              <a:t>Epic-grouped with signoff workflow</a:t>
             </a:r>
           </a:p>
         </p:txBody>
@@ -8567,71 +10222,60 @@
               </a:defRPr>
             </a:pPr>
             <a:r>
-              <a:t>PURPOSE: Visual grid showing teams vs products with sprint progress.</a:t>
-            </a:r>
-            <a:br/>
-            <a:br/>
-            <a:r>
-              <a:t>HOW IT WORKS:</a:t>
-            </a:r>
-            <a:br/>
-            <a:r>
-              <a:t>• Teams (rows) derived from resource assignments → epics</a:t>
-            </a:r>
-            <a:br/>
-            <a:r>
-              <a:t>• Products (columns) from release items → stories → epics</a:t>
-            </a:r>
-            <a:br/>
-            <a:r>
-              <a:t>  → projects → products</a:t>
-            </a:r>
-            <a:br/>
-            <a:br/>
-            <a:r>
-              <a:t>SPRINT CARD SHOWS:</a:t>
-            </a:r>
-            <a:br/>
-            <a:r>
-              <a:t>• Sprint name &amp; status badge</a:t>
-            </a:r>
-            <a:br/>
-            <a:r>
-              <a:t>• Release &amp; cutoff dates</a:t>
-            </a:r>
-            <a:br/>
-            <a:r>
-              <a:t>• Story count &amp; signoff progress</a:t>
-            </a:r>
-            <a:br/>
-            <a:r>
-              <a:t>• Story Points: completed/total (e.g., 21/26 SP)</a:t>
-            </a:r>
-            <a:br/>
-            <a:r>
-              <a:t>• Progress bar for pending signoffs</a:t>
-            </a:r>
-            <a:br/>
-            <a:br/>
-            <a:r>
-              <a:t>FILTERS:</a:t>
-            </a:r>
-            <a:br/>
-            <a:r>
-              <a:t>• ☑ Active only toggle (hide Released sprints)</a:t>
-            </a:r>
-            <a:br/>
-            <a:r>
-              <a:t>• VSO: sees only their VS products</a:t>
-            </a:r>
-            <a:br/>
-            <a:r>
-              <a:t>• BA: sees only products with active demands</a:t>
-            </a:r>
-            <a:br/>
-            <a:br/>
-            <a:r>
-              <a:t>Click card → navigates to Releases tab with auto-expand</a:t>
+              <a:t>PURPOSE: Manage the release lifecycle from draft to released.</a:t>
+            </a:r>
+            <a:br/>
+            <a:br/>
+            <a:r>
+              <a:t>LIFECYCLE: Draft → Open → In Review → Released</a:t>
+            </a:r>
+            <a:br/>
+            <a:r>
+              <a:t>  (workflow buttons appear based on current status)</a:t>
+            </a:r>
+            <a:br/>
+            <a:br/>
+            <a:r>
+              <a:t>REGISTERING STORIES:</a:t>
+            </a:r>
+            <a:br/>
+            <a:r>
+              <a:t>• Click ➕ Register on an Open release</a:t>
+            </a:r>
+            <a:br/>
+            <a:r>
+              <a:t>• Select unregistered user stories (grouped by epic)</a:t>
+            </a:r>
+            <a:br/>
+            <a:r>
+              <a:t>• Two-level expand: Release → Epics → Stories</a:t>
+            </a:r>
+            <a:br/>
+            <a:br/>
+            <a:r>
+              <a:t>SIGNOFF WORKFLOW:</a:t>
+            </a:r>
+            <a:br/>
+            <a:r>
+              <a:t>• Individual story signoff: Pending → Approved / Rejected</a:t>
+            </a:r>
+            <a:br/>
+            <a:r>
+              <a:t>• ✍️ Signoff modal: Decision + Note</a:t>
+            </a:r>
+            <a:br/>
+            <a:r>
+              <a:t>• Signoff recorded with by/date metadata</a:t>
+            </a:r>
+            <a:br/>
+            <a:br/>
+            <a:r>
+              <a:t>Click any row → expands epics → expands stories</a:t>
+            </a:r>
+            <a:br/>
+            <a:br/>
+            <a:r>
+              <a:t>ACCESS: All roles (edit restricted)</a:t>
             </a:r>
           </a:p>
         </p:txBody>
@@ -8666,7 +10310,7 @@
               </a:defRPr>
             </a:pPr>
             <a:r>
-              <a:t>26/33</a:t>
+              <a:t>26/34</a:t>
             </a:r>
           </a:p>
         </p:txBody>
@@ -8805,7 +10449,7 @@
               </a:defRPr>
             </a:pPr>
             <a:r>
-              <a:t>✅ Governance Checklist</a:t>
+              <a:t>📋 Sprint Board</a:t>
             </a:r>
           </a:p>
         </p:txBody>
@@ -8840,7 +10484,7 @@
               </a:defRPr>
             </a:pPr>
             <a:r>
-              <a:t>Config-driven phases and tasks per project</a:t>
+              <a:t>Team × Product matrix with SP tracking</a:t>
             </a:r>
           </a:p>
         </p:txBody>
@@ -8878,49 +10522,49 @@
               </a:defRPr>
             </a:pPr>
             <a:r>
-              <a:t>PURPOSE: Per-project governance tracking with configurable phases.</a:t>
-            </a:r>
-            <a:br/>
-            <a:br/>
-            <a:r>
-              <a:t>TEMPLATE SYSTEM:</a:t>
-            </a:r>
-            <a:br/>
-            <a:r>
-              <a:t>• Each project has a governance template (auto-detect or explicit)</a:t>
-            </a:r>
-            <a:br/>
-            <a:r>
-              <a:t>• Template determines phases (from project_phase config)</a:t>
-            </a:r>
-            <a:br/>
-            <a:r>
-              <a:t>• Each phase has checklist items (from project_checklist config)</a:t>
-            </a:r>
-            <a:br/>
-            <a:r>
-              <a:t>• VS-specific or default templates available</a:t>
-            </a:r>
-            <a:br/>
-            <a:br/>
-            <a:r>
-              <a:t>EDITING:</a:t>
-            </a:r>
-            <a:br/>
-            <a:r>
-              <a:t>• Status dropdown: To Do / In Progress / Done / N/A</a:t>
-            </a:r>
-            <a:br/>
-            <a:r>
-              <a:t>• Owner, Plan Start/End, Actual Start/End — inline editable</a:t>
-            </a:r>
-            <a:br/>
-            <a:r>
-              <a:t>• Config-only items auto-create on first edit</a:t>
-            </a:r>
-            <a:br/>
-            <a:r>
-              <a:t>• 'Generate N Items' creates all missing items at once</a:t>
+              <a:t>PURPOSE: Visual grid showing teams vs products with sprint progress.</a:t>
+            </a:r>
+            <a:br/>
+            <a:br/>
+            <a:r>
+              <a:t>HOW IT WORKS:</a:t>
+            </a:r>
+            <a:br/>
+            <a:r>
+              <a:t>• Teams (rows) derived from resource assignments → epics</a:t>
+            </a:r>
+            <a:br/>
+            <a:r>
+              <a:t>• Products (columns) from release items → stories → epics</a:t>
+            </a:r>
+            <a:br/>
+            <a:r>
+              <a:t>  → projects → products</a:t>
+            </a:r>
+            <a:br/>
+            <a:br/>
+            <a:r>
+              <a:t>SPRINT CARD SHOWS:</a:t>
+            </a:r>
+            <a:br/>
+            <a:r>
+              <a:t>• Sprint name &amp; status badge</a:t>
+            </a:r>
+            <a:br/>
+            <a:r>
+              <a:t>• Release &amp; cutoff dates</a:t>
+            </a:r>
+            <a:br/>
+            <a:r>
+              <a:t>• Story count &amp; signoff progress</a:t>
+            </a:r>
+            <a:br/>
+            <a:r>
+              <a:t>• Story Points: completed/total (e.g., 21/26 SP)</a:t>
+            </a:r>
+            <a:br/>
+            <a:r>
+              <a:t>• Progress bar for pending signoffs</a:t>
             </a:r>
             <a:br/>
             <a:br/>
@@ -8929,16 +10573,20 @@
             </a:r>
             <a:br/>
             <a:r>
-              <a:t>• Project dropdown + Phase dropdown + Search bar</a:t>
-            </a:r>
-            <a:br/>
-            <a:br/>
-            <a:r>
-              <a:t>ROLE: VSO sees only their VS projects; BA sees demand-linked</a:t>
-            </a:r>
-            <a:br/>
-            <a:r>
-              <a:t>  projects; edit restricted to Admin/DL/VSO/PO/RM/VSPMO</a:t>
+              <a:t>• ☑ Active only toggle (hide Released sprints)</a:t>
+            </a:r>
+            <a:br/>
+            <a:r>
+              <a:t>• VSO: sees only their VS products</a:t>
+            </a:r>
+            <a:br/>
+            <a:r>
+              <a:t>• BA: sees only products with active demands</a:t>
+            </a:r>
+            <a:br/>
+            <a:br/>
+            <a:r>
+              <a:t>Click card → navigates to Releases tab with auto-expand</a:t>
             </a:r>
           </a:p>
         </p:txBody>
@@ -8973,7 +10621,7 @@
               </a:defRPr>
             </a:pPr>
             <a:r>
-              <a:t>27/33</a:t>
+              <a:t>27/34</a:t>
             </a:r>
           </a:p>
         </p:txBody>
@@ -9112,7 +10760,7 @@
               </a:defRPr>
             </a:pPr>
             <a:r>
-              <a:t>👥 Resources</a:t>
+              <a:t>✅ Governance Checklist</a:t>
             </a:r>
           </a:p>
         </p:txBody>
@@ -9147,7 +10795,7 @@
               </a:defRPr>
             </a:pPr>
             <a:r>
-              <a:t>People management with team and department tracking</a:t>
+              <a:t>Config-driven phases and tasks per project</a:t>
             </a:r>
           </a:p>
         </p:txBody>
@@ -9185,54 +10833,67 @@
               </a:defRPr>
             </a:pPr>
             <a:r>
-              <a:t>PURPOSE: Manage human resources / team members.</a:t>
-            </a:r>
-            <a:br/>
-            <a:br/>
-            <a:r>
-              <a:t>FEATURES:</a:t>
-            </a:r>
-            <a:br/>
-            <a:r>
-              <a:t>• Create/Edit/Delete resources</a:t>
-            </a:r>
-            <a:br/>
-            <a:r>
-              <a:t>• Each resource has: Name, Role, Department, Team</a:t>
-            </a:r>
-            <a:br/>
-            <a:r>
-              <a:t>• Email, Joined/Leave dates</a:t>
-            </a:r>
-            <a:br/>
-            <a:r>
-              <a:t>• Cost (monthly) for budgeting</a:t>
-            </a:r>
-            <a:br/>
-            <a:r>
-              <a:t>• Status (Active/Inactive/On Leave)</a:t>
-            </a:r>
-            <a:br/>
-            <a:br/>
-            <a:r>
-              <a:t>RELATIONSHIPS:</a:t>
-            </a:r>
-            <a:br/>
-            <a:r>
-              <a:t>• Resources assigned to epics via pm_assignment</a:t>
-            </a:r>
-            <a:br/>
-            <a:r>
-              <a:t>  (allocation %, start/end dates)</a:t>
-            </a:r>
-            <a:br/>
-            <a:r>
-              <a:t>• Team derived from resource → determines Sprint Board rows</a:t>
-            </a:r>
-            <a:br/>
-            <a:br/>
-            <a:r>
-              <a:t>ACCESS: Admin, VSPMO, DL, BA (plus Users tab for DL)</a:t>
+              <a:t>PURPOSE: Per-project governance tracking with configurable phases.</a:t>
+            </a:r>
+            <a:br/>
+            <a:br/>
+            <a:r>
+              <a:t>TEMPLATE SYSTEM:</a:t>
+            </a:r>
+            <a:br/>
+            <a:r>
+              <a:t>• Each project has a governance template (auto-detect or explicit)</a:t>
+            </a:r>
+            <a:br/>
+            <a:r>
+              <a:t>• Template determines phases (from project_phase config)</a:t>
+            </a:r>
+            <a:br/>
+            <a:r>
+              <a:t>• Each phase has checklist items (from project_checklist config)</a:t>
+            </a:r>
+            <a:br/>
+            <a:r>
+              <a:t>• VS-specific or default templates available</a:t>
+            </a:r>
+            <a:br/>
+            <a:br/>
+            <a:r>
+              <a:t>EDITING:</a:t>
+            </a:r>
+            <a:br/>
+            <a:r>
+              <a:t>• Status dropdown: To Do / In Progress / Done / N/A</a:t>
+            </a:r>
+            <a:br/>
+            <a:r>
+              <a:t>• Owner, Plan Start/End, Actual Start/End — inline editable</a:t>
+            </a:r>
+            <a:br/>
+            <a:r>
+              <a:t>• Config-only items auto-create on first edit</a:t>
+            </a:r>
+            <a:br/>
+            <a:r>
+              <a:t>• 'Generate N Items' creates all missing items at once</a:t>
+            </a:r>
+            <a:br/>
+            <a:br/>
+            <a:r>
+              <a:t>FILTERS:</a:t>
+            </a:r>
+            <a:br/>
+            <a:r>
+              <a:t>• Project dropdown + Phase dropdown + Search bar</a:t>
+            </a:r>
+            <a:br/>
+            <a:br/>
+            <a:r>
+              <a:t>ROLE: VSO sees only their VS projects; BA sees demand-linked</a:t>
+            </a:r>
+            <a:br/>
+            <a:r>
+              <a:t>  projects; edit restricted to Admin/DL/VSO/PO/RM/VSPMO</a:t>
             </a:r>
           </a:p>
         </p:txBody>
@@ -9267,7 +10928,7 @@
               </a:defRPr>
             </a:pPr>
             <a:r>
-              <a:t>28/33</a:t>
+              <a:t>28/34</a:t>
             </a:r>
           </a:p>
         </p:txBody>
@@ -9406,7 +11067,7 @@
               </a:defRPr>
             </a:pPr>
             <a:r>
-              <a:t>👤 Users &amp; Roles</a:t>
+              <a:t>👥 Resources</a:t>
             </a:r>
           </a:p>
         </p:txBody>
@@ -9441,7 +11102,7 @@
               </a:defRPr>
             </a:pPr>
             <a:r>
-              <a:t>User management with role assignment</a:t>
+              <a:t>People management with team and department tracking</a:t>
             </a:r>
           </a:p>
         </p:txBody>
@@ -9479,7 +11140,7 @@
               </a:defRPr>
             </a:pPr>
             <a:r>
-              <a:t>PURPOSE: Manage who can access the system and what they can do.</a:t>
+              <a:t>PURPOSE: Manage human resources / team members.</a:t>
             </a:r>
             <a:br/>
             <a:br/>
@@ -9488,62 +11149,45 @@
             </a:r>
             <a:br/>
             <a:r>
-              <a:t>• Create/Edit/Delete users</a:t>
-            </a:r>
-            <a:br/>
-            <a:r>
-              <a:t>• Each user has: Username, Display Name, Email</a:t>
-            </a:r>
-            <a:br/>
-            <a:r>
-              <a:t>• Role assignment (single role per user)</a:t>
-            </a:r>
-            <a:br/>
-            <a:r>
-              <a:t>• VSO users: assign value streams via checkboxes</a:t>
-            </a:r>
-            <a:br/>
-            <a:r>
-              <a:t>  (pm_valuestream = comma-separated VS config IDs)</a:t>
-            </a:r>
-            <a:br/>
-            <a:r>
-              <a:t>• Status field (active/inactive)</a:t>
-            </a:r>
-            <a:br/>
-            <a:br/>
-            <a:r>
-              <a:t>ROLES AVAILABLE:</a:t>
-            </a:r>
-            <a:br/>
-            <a:r>
-              <a:t>• Admin, Value Stream PMO, Value Stream Owner, Product Owner,</a:t>
-            </a:r>
-            <a:br/>
-            <a:r>
-              <a:t>  Delivery Lead, Business Analyst, Release Manager, ITSO</a:t>
-            </a:r>
-            <a:br/>
-            <a:br/>
-            <a:r>
-              <a:t>ROLE SELECTOR:</a:t>
-            </a:r>
-            <a:br/>
-            <a:r>
-              <a:t>• Header dropdown to switch roles (DEV mode)</a:t>
-            </a:r>
-            <a:br/>
-            <a:r>
-              <a:t>• Persisted in localStorage</a:t>
-            </a:r>
-            <a:br/>
-            <a:r>
-              <a:t>• Tab visibility and edit permissions change accordingly</a:t>
-            </a:r>
-            <a:br/>
-            <a:br/>
-            <a:r>
-              <a:t>ACCESS: Admin, DL</a:t>
+              <a:t>• Create/Edit/Delete resources</a:t>
+            </a:r>
+            <a:br/>
+            <a:r>
+              <a:t>• Each resource has: Name, Role, Department, Team</a:t>
+            </a:r>
+            <a:br/>
+            <a:r>
+              <a:t>• Email, Joined/Leave dates</a:t>
+            </a:r>
+            <a:br/>
+            <a:r>
+              <a:t>• Cost (monthly) for budgeting</a:t>
+            </a:r>
+            <a:br/>
+            <a:r>
+              <a:t>• Status (Active/Inactive/On Leave)</a:t>
+            </a:r>
+            <a:br/>
+            <a:br/>
+            <a:r>
+              <a:t>RELATIONSHIPS:</a:t>
+            </a:r>
+            <a:br/>
+            <a:r>
+              <a:t>• Resources assigned to epics via pm_assignment</a:t>
+            </a:r>
+            <a:br/>
+            <a:r>
+              <a:t>  (allocation %, start/end dates)</a:t>
+            </a:r>
+            <a:br/>
+            <a:r>
+              <a:t>• Team derived from resource → determines Sprint Board rows</a:t>
+            </a:r>
+            <a:br/>
+            <a:br/>
+            <a:r>
+              <a:t>ACCESS: Admin, VSPMO, DL, BA (plus Users tab for DL)</a:t>
             </a:r>
           </a:p>
         </p:txBody>
@@ -9578,7 +11222,7 @@
               </a:defRPr>
             </a:pPr>
             <a:r>
-              <a:t>29/33</a:t>
+              <a:t>29/34</a:t>
             </a:r>
           </a:p>
         </p:txBody>
@@ -9817,7 +11461,7 @@
               </a:defRPr>
             </a:pPr>
             <a:r>
-              <a:t>3/33</a:t>
+              <a:t>3/34</a:t>
             </a:r>
           </a:p>
         </p:txBody>
@@ -9956,7 +11600,7 @@
               </a:defRPr>
             </a:pPr>
             <a:r>
-              <a:t>⚙️ Configuration</a:t>
+              <a:t>👤 Users &amp; Roles</a:t>
             </a:r>
           </a:p>
         </p:txBody>
@@ -9991,7 +11635,7 @@
               </a:defRPr>
             </a:pPr>
             <a:r>
-              <a:t>Manage all dropdown options and workflow definitions</a:t>
+              <a:t>User management with role assignment</a:t>
             </a:r>
           </a:p>
         </p:txBody>
@@ -10029,75 +11673,71 @@
               </a:defRPr>
             </a:pPr>
             <a:r>
-              <a:t>PURPOSE: Central configuration for all configurable values.</a:t>
-            </a:r>
-            <a:br/>
-            <a:br/>
-            <a:r>
-              <a:t>CONFIG TYPES (21):</a:t>
-            </a:r>
-            <a:br/>
-            <a:r>
-              <a:t>• value_stream, team, department, enhancement_type</a:t>
-            </a:r>
-            <a:br/>
-            <a:r>
-              <a:t>• capability_type, governance_status, priority</a:t>
-            </a:r>
-            <a:br/>
-            <a:r>
-              <a:t>• rag_status, requirement_status, psc_approval_status</a:t>
-            </a:r>
-            <a:br/>
-            <a:r>
-              <a:t>• signoff_status, resource_status, project_status</a:t>
-            </a:r>
-            <a:br/>
-            <a:r>
-              <a:t>• release_status, yes_no, tool, demand_type</a:t>
-            </a:r>
-            <a:br/>
-            <a:r>
-              <a:t>• demand_flow (workflow definitions)</a:t>
-            </a:r>
-            <a:br/>
-            <a:r>
-              <a:t>• user_role, project_phase, project_checklist</a:t>
-            </a:r>
-            <a:br/>
-            <a:br/>
-            <a:r>
-              <a:t>WHAT YOU CAN DO:</a:t>
-            </a:r>
-            <a:br/>
-            <a:r>
-              <a:t>• Add new config entries (e.g., new priority level)</a:t>
-            </a:r>
-            <a:br/>
-            <a:r>
-              <a:t>• Edit existing entries</a:t>
-            </a:r>
-            <a:br/>
-            <a:r>
-              <a:t>• Delete unused entries</a:t>
-            </a:r>
-            <a:br/>
-            <a:r>
-              <a:t>• Change workflow steps (demand_flow)</a:t>
-            </a:r>
-            <a:br/>
-            <a:r>
-              <a:t>• Add/remove governance phases and checklist items</a:t>
-            </a:r>
-            <a:br/>
-            <a:br/>
-            <a:r>
-              <a:t>💡 Changes take effect immediately — no code changes needed</a:t>
-            </a:r>
-            <a:br/>
-            <a:br/>
-            <a:r>
-              <a:t>ACCESS: Admin only</a:t>
+              <a:t>PURPOSE: Manage who can access the system and what they can do.</a:t>
+            </a:r>
+            <a:br/>
+            <a:br/>
+            <a:r>
+              <a:t>FEATURES:</a:t>
+            </a:r>
+            <a:br/>
+            <a:r>
+              <a:t>• Create/Edit/Delete users</a:t>
+            </a:r>
+            <a:br/>
+            <a:r>
+              <a:t>• Each user has: Username, Display Name, Email</a:t>
+            </a:r>
+            <a:br/>
+            <a:r>
+              <a:t>• Role assignment (single role per user)</a:t>
+            </a:r>
+            <a:br/>
+            <a:r>
+              <a:t>• VSO users: assign value streams via checkboxes</a:t>
+            </a:r>
+            <a:br/>
+            <a:r>
+              <a:t>  (pm_valuestream = comma-separated VS config IDs)</a:t>
+            </a:r>
+            <a:br/>
+            <a:r>
+              <a:t>• Status field (active/inactive)</a:t>
+            </a:r>
+            <a:br/>
+            <a:br/>
+            <a:r>
+              <a:t>ROLES AVAILABLE:</a:t>
+            </a:r>
+            <a:br/>
+            <a:r>
+              <a:t>• Admin, Value Stream PMO, Value Stream Owner, Product Owner,</a:t>
+            </a:r>
+            <a:br/>
+            <a:r>
+              <a:t>  Delivery Lead, Business Analyst, Release Manager, ITSO</a:t>
+            </a:r>
+            <a:br/>
+            <a:br/>
+            <a:r>
+              <a:t>ROLE SELECTOR:</a:t>
+            </a:r>
+            <a:br/>
+            <a:r>
+              <a:t>• Header dropdown to switch roles (DEV mode)</a:t>
+            </a:r>
+            <a:br/>
+            <a:r>
+              <a:t>• Persisted in localStorage</a:t>
+            </a:r>
+            <a:br/>
+            <a:r>
+              <a:t>• Tab visibility and edit permissions change accordingly</a:t>
+            </a:r>
+            <a:br/>
+            <a:br/>
+            <a:r>
+              <a:t>ACCESS: Admin, DL</a:t>
             </a:r>
           </a:p>
         </p:txBody>
@@ -10132,7 +11772,7 @@
               </a:defRPr>
             </a:pPr>
             <a:r>
-              <a:t>30/33</a:t>
+              <a:t>30/34</a:t>
             </a:r>
           </a:p>
         </p:txBody>
@@ -10271,7 +11911,7 @@
               </a:defRPr>
             </a:pPr>
             <a:r>
-              <a:t>🔒 Project Lock &amp; 📦 Requirement Unlink</a:t>
+              <a:t>⚙️ Configuration</a:t>
             </a:r>
           </a:p>
         </p:txBody>
@@ -10306,7 +11946,7 @@
               </a:defRPr>
             </a:pPr>
             <a:r>
-              <a:t>Scope control — freeze and descope</a:t>
+              <a:t>Manage all dropdown options and workflow definitions</a:t>
             </a:r>
           </a:p>
         </p:txBody>
@@ -10344,65 +11984,75 @@
               </a:defRPr>
             </a:pPr>
             <a:r>
-              <a:t>PROJECT LOCK (🔒):</a:t>
-            </a:r>
-            <a:br/>
-            <a:r>
-              <a:t>• Toggle button on each project row in 📁 Projects</a:t>
-            </a:r>
-            <a:br/>
-            <a:r>
-              <a:t>• When locked (pm_locked = 'Yes'):</a:t>
-            </a:r>
-            <a:br/>
-            <a:r>
-              <a:t>  — No new requirements can be linked to this project</a:t>
-            </a:r>
-            <a:br/>
-            <a:r>
-              <a:t>  — Existing requirements cannot be edited</a:t>
-            </a:r>
-            <a:br/>
-            <a:r>
-              <a:t>  — Locked projects hidden from 'Link to Project' dropdowns</a:t>
-            </a:r>
-            <a:br/>
-            <a:r>
-              <a:t>• 🔒 icon shown next to locked project names everywhere</a:t>
-            </a:r>
-            <a:br/>
-            <a:br/>
-            <a:r>
-              <a:t>REQUIREMENT UNLINK (📦 Backlog):</a:t>
-            </a:r>
-            <a:br/>
-            <a:r>
-              <a:t>• Button on each linked requirement in 📋 Requirements</a:t>
-            </a:r>
-            <a:br/>
-            <a:r>
-              <a:t>• Clears pm_projectname, sets status to 'Prioritized'</a:t>
-            </a:r>
-            <a:br/>
-            <a:r>
-              <a:t>• Item returns to Backlog pool</a:t>
-            </a:r>
-            <a:br/>
-            <a:r>
-              <a:t>• Works even on locked projects (for descoping)</a:t>
-            </a:r>
-            <a:br/>
-            <a:br/>
-            <a:r>
-              <a:t>WHO CAN DO IT:</a:t>
-            </a:r>
-            <a:br/>
-            <a:r>
-              <a:t>• 🔒 Lock/Unlock project: Admin, Value Stream PMO, Value Stream Owner</a:t>
-            </a:r>
-            <a:br/>
-            <a:r>
-              <a:t>• 📦 Move to Backlog: Admin, Value Stream PMO, Value Stream Owner</a:t>
+              <a:t>PURPOSE: Central configuration for all configurable values.</a:t>
+            </a:r>
+            <a:br/>
+            <a:br/>
+            <a:r>
+              <a:t>CONFIG TYPES (21):</a:t>
+            </a:r>
+            <a:br/>
+            <a:r>
+              <a:t>• value_stream, team, department, enhancement_type</a:t>
+            </a:r>
+            <a:br/>
+            <a:r>
+              <a:t>• capability_type, governance_status, priority</a:t>
+            </a:r>
+            <a:br/>
+            <a:r>
+              <a:t>• rag_status, requirement_status, psc_approval_status</a:t>
+            </a:r>
+            <a:br/>
+            <a:r>
+              <a:t>• signoff_status, resource_status, project_status</a:t>
+            </a:r>
+            <a:br/>
+            <a:r>
+              <a:t>• release_status, yes_no, tool, demand_type</a:t>
+            </a:r>
+            <a:br/>
+            <a:r>
+              <a:t>• demand_flow (workflow definitions)</a:t>
+            </a:r>
+            <a:br/>
+            <a:r>
+              <a:t>• user_role, project_phase, project_checklist</a:t>
+            </a:r>
+            <a:br/>
+            <a:br/>
+            <a:r>
+              <a:t>WHAT YOU CAN DO:</a:t>
+            </a:r>
+            <a:br/>
+            <a:r>
+              <a:t>• Add new config entries (e.g., new priority level)</a:t>
+            </a:r>
+            <a:br/>
+            <a:r>
+              <a:t>• Edit existing entries</a:t>
+            </a:r>
+            <a:br/>
+            <a:r>
+              <a:t>• Delete unused entries</a:t>
+            </a:r>
+            <a:br/>
+            <a:r>
+              <a:t>• Change workflow steps (demand_flow)</a:t>
+            </a:r>
+            <a:br/>
+            <a:r>
+              <a:t>• Add/remove governance phases and checklist items</a:t>
+            </a:r>
+            <a:br/>
+            <a:br/>
+            <a:r>
+              <a:t>💡 Changes take effect immediately — no code changes needed</a:t>
+            </a:r>
+            <a:br/>
+            <a:br/>
+            <a:r>
+              <a:t>ACCESS: Admin only</a:t>
             </a:r>
           </a:p>
         </p:txBody>
@@ -10437,7 +12087,7 @@
               </a:defRPr>
             </a:pPr>
             <a:r>
-              <a:t>31/33</a:t>
+              <a:t>31/34</a:t>
             </a:r>
           </a:p>
         </p:txBody>
@@ -10576,7 +12226,7 @@
               </a:defRPr>
             </a:pPr>
             <a:r>
-              <a:t>Getting Started — Quick Reference</a:t>
+              <a:t>🔒 Project Lock &amp; 📦 Requirement Unlink</a:t>
             </a:r>
           </a:p>
         </p:txBody>
@@ -10584,6 +12234,41 @@
       <p:sp>
         <p:nvSpPr>
           <p:cNvPr id="4" name="TextBox 3"/>
+          <p:cNvSpPr txBox="1"/>
+          <p:nvPr/>
+        </p:nvSpPr>
+        <p:spPr>
+          <a:xfrm>
+            <a:off x="731520" y="658368"/>
+            <a:ext cx="10515600" cy="320040"/>
+          </a:xfrm>
+          <a:prstGeom prst="rect">
+            <a:avLst/>
+          </a:prstGeom>
+          <a:noFill/>
+        </p:spPr>
+        <p:txBody>
+          <a:bodyPr wrap="none">
+            <a:spAutoFit/>
+          </a:bodyPr>
+          <a:lstStyle/>
+          <a:p>
+            <a:pPr algn="l">
+              <a:defRPr sz="1400">
+                <a:solidFill>
+                  <a:srgbClr val="C7D2FE"/>
+                </a:solidFill>
+              </a:defRPr>
+            </a:pPr>
+            <a:r>
+              <a:t>Scope control — freeze and descope</a:t>
+            </a:r>
+          </a:p>
+        </p:txBody>
+      </p:sp>
+      <p:sp>
+        <p:nvSpPr>
+          <p:cNvPr id="5" name="TextBox 4"/>
           <p:cNvSpPr txBox="1"/>
           <p:nvPr/>
         </p:nvSpPr>
@@ -10614,104 +12299,72 @@
               </a:defRPr>
             </a:pPr>
             <a:r>
-              <a:t>1️⃣ RAISE A DEMAND: 📥 Demand → + Raise Demand</a:t>
-            </a:r>
-            <a:br/>
-            <a:r>
-              <a:t>  → Select Value Stream (determines workflow)</a:t>
-            </a:r>
-            <a:br/>
-            <a:br/>
-            <a:r>
-              <a:t>2️⃣ ADVANCE WORKFLOW: Click Change Status on a demand</a:t>
-            </a:r>
-            <a:br/>
-            <a:r>
-              <a:t>  → Last step (Approved) creates a Requirement</a:t>
-            </a:r>
-            <a:br/>
-            <a:br/>
-            <a:r>
-              <a:t>3️⃣ CREATE A PROJECT: 📁 Projects → + New Project</a:t>
-            </a:r>
-            <a:br/>
-            <a:r>
-              <a:t>  → Assign a Governance Template if needed</a:t>
-            </a:r>
-            <a:br/>
-            <a:br/>
-            <a:r>
-              <a:t>4️⃣ MANAGE EPICS &amp; STORIES: Break down requirements</a:t>
-            </a:r>
-            <a:br/>
-            <a:r>
-              <a:t>  → Assign resources to epics (determines Sprint Board teams)</a:t>
-            </a:r>
-            <a:br/>
-            <a:br/>
-            <a:r>
-              <a:t>5️⃣ GOVERNANCE CHECKLIST: ✅ Governance</a:t>
-            </a:r>
-            <a:br/>
-            <a:r>
-              <a:t>  → Generate Items or edit items individually</a:t>
-            </a:r>
-            <a:br/>
-            <a:br/>
-            <a:r>
-              <a:t>6️⃣ CREATE A RELEASE: 🚀 Releases → + New Release</a:t>
-            </a:r>
-            <a:br/>
-            <a:r>
-              <a:t>  → Register stories, sign off when ready</a:t>
-            </a:r>
-            <a:br/>
-            <a:br/>
-            <a:r>
-              <a:t>7️⃣ VIEW SPRINTS: 📋 Sprint Board for Team×Product grid</a:t>
-            </a:r>
-            <a:br/>
-            <a:r>
-              <a:t>  → Toggle 'Active only' as needed</a:t>
-            </a:r>
-            <a:br/>
-            <a:br/>
-            <a:r>
-              <a:t>8️⃣ CHECK PORTFOLIO: 📈 Portfolio for holistic VS view</a:t>
-            </a:r>
-            <a:br/>
-            <a:br/>
-            <a:r>
-              <a:t>9️⃣ LOCK PROJECT: 📁 Projects → 🔒 Lock button</a:t>
-            </a:r>
-            <a:br/>
-            <a:r>
-              <a:t>  → Admin/VSPMO/VSO only</a:t>
-            </a:r>
-            <a:br/>
-            <a:br/>
-            <a:r>
-              <a:t>🔟 UNLINK REQUIREMENT: 📋 Requirements → 📦 Backlog</a:t>
-            </a:r>
-            <a:br/>
-            <a:r>
-              <a:t>  → Moves item back to backlog pool</a:t>
-            </a:r>
-            <a:br/>
-            <a:br/>
-            <a:r>
-              <a:t>👤 SWITCH ROLE: Use role dropdown in header (DEV mode)</a:t>
-            </a:r>
-            <a:br/>
-            <a:r>
-              <a:t>🔄 RESET DATA: Click 🔄 Reset in header to clear all seed data</a:t>
-            </a:r>
-          </a:p>
-        </p:txBody>
-      </p:sp>
-      <p:sp>
-        <p:nvSpPr>
-          <p:cNvPr id="5" name="TextBox 4"/>
+              <a:t>PROJECT LOCK (🔒):</a:t>
+            </a:r>
+            <a:br/>
+            <a:r>
+              <a:t>• Toggle button on each project row in 📁 Projects</a:t>
+            </a:r>
+            <a:br/>
+            <a:r>
+              <a:t>• When locked (pm_locked = 'Yes'):</a:t>
+            </a:r>
+            <a:br/>
+            <a:r>
+              <a:t>  — No new requirements can be linked to this project</a:t>
+            </a:r>
+            <a:br/>
+            <a:r>
+              <a:t>  — Existing requirements cannot be edited</a:t>
+            </a:r>
+            <a:br/>
+            <a:r>
+              <a:t>  — Locked projects hidden from 'Link to Project' dropdowns</a:t>
+            </a:r>
+            <a:br/>
+            <a:r>
+              <a:t>• 🔒 icon shown next to locked project names everywhere</a:t>
+            </a:r>
+            <a:br/>
+            <a:br/>
+            <a:r>
+              <a:t>REQUIREMENT UNLINK (📦 Backlog):</a:t>
+            </a:r>
+            <a:br/>
+            <a:r>
+              <a:t>• Button on each linked requirement in 📋 Requirements</a:t>
+            </a:r>
+            <a:br/>
+            <a:r>
+              <a:t>• Clears pm_projectname, sets status to 'Prioritized'</a:t>
+            </a:r>
+            <a:br/>
+            <a:r>
+              <a:t>• Item returns to Backlog pool</a:t>
+            </a:r>
+            <a:br/>
+            <a:r>
+              <a:t>• Works even on locked projects (for descoping)</a:t>
+            </a:r>
+            <a:br/>
+            <a:br/>
+            <a:r>
+              <a:t>WHO CAN DO IT:</a:t>
+            </a:r>
+            <a:br/>
+            <a:r>
+              <a:t>• 🔒 Lock/Unlock project: Admin, Value Stream PMO, Value Stream Owner</a:t>
+            </a:r>
+            <a:br/>
+            <a:r>
+              <a:t>• 📦 Move to Backlog: Admin, Value Stream PMO, Value Stream Owner</a:t>
+            </a:r>
+          </a:p>
+        </p:txBody>
+      </p:sp>
+      <p:sp>
+        <p:nvSpPr>
+          <p:cNvPr id="6" name="TextBox 5"/>
           <p:cNvSpPr txBox="1"/>
           <p:nvPr/>
         </p:nvSpPr>
@@ -10739,14 +12392,14 @@
               </a:defRPr>
             </a:pPr>
             <a:r>
-              <a:t>32/33</a:t>
-            </a:r>
-          </a:p>
-        </p:txBody>
-      </p:sp>
-      <p:sp>
-        <p:nvSpPr>
-          <p:cNvPr id="6" name="TextBox 5"/>
+              <a:t>32/34</a:t>
+            </a:r>
+          </a:p>
+        </p:txBody>
+      </p:sp>
+      <p:sp>
+        <p:nvSpPr>
+          <p:cNvPr id="7" name="TextBox 6"/>
           <p:cNvSpPr txBox="1"/>
           <p:nvPr/>
         </p:nvSpPr>
@@ -10878,6 +12531,308 @@
               </a:defRPr>
             </a:pPr>
             <a:r>
+              <a:t>Getting Started — Quick Reference</a:t>
+            </a:r>
+          </a:p>
+        </p:txBody>
+      </p:sp>
+      <p:sp>
+        <p:nvSpPr>
+          <p:cNvPr id="4" name="TextBox 3"/>
+          <p:cNvSpPr txBox="1"/>
+          <p:nvPr/>
+        </p:nvSpPr>
+        <p:spPr>
+          <a:xfrm>
+            <a:off x="731520" y="1371600"/>
+            <a:ext cx="10698480" cy="5029200"/>
+          </a:xfrm>
+          <a:prstGeom prst="rect">
+            <a:avLst/>
+          </a:prstGeom>
+          <a:noFill/>
+        </p:spPr>
+        <p:txBody>
+          <a:bodyPr wrap="square">
+            <a:spAutoFit/>
+          </a:bodyPr>
+          <a:lstStyle/>
+          <a:p>
+            <a:pPr>
+              <a:lnSpc>
+                <a:spcPts val="1900"/>
+              </a:lnSpc>
+              <a:defRPr sz="1300">
+                <a:solidFill>
+                  <a:srgbClr val="0F172A"/>
+                </a:solidFill>
+              </a:defRPr>
+            </a:pPr>
+            <a:r>
+              <a:t>1️⃣ RAISE A DEMAND: 📥 Demand → + Raise Demand</a:t>
+            </a:r>
+            <a:br/>
+            <a:r>
+              <a:t>  → Select Value Stream (determines workflow)</a:t>
+            </a:r>
+            <a:br/>
+            <a:br/>
+            <a:r>
+              <a:t>2️⃣ ADVANCE WORKFLOW: Click Change Status on a demand</a:t>
+            </a:r>
+            <a:br/>
+            <a:r>
+              <a:t>  → Last step (Approved) creates a Requirement</a:t>
+            </a:r>
+            <a:br/>
+            <a:br/>
+            <a:r>
+              <a:t>3️⃣ CREATE A PROJECT: 📁 Projects → + New Project</a:t>
+            </a:r>
+            <a:br/>
+            <a:r>
+              <a:t>  → Assign a Governance Template if needed</a:t>
+            </a:r>
+            <a:br/>
+            <a:br/>
+            <a:r>
+              <a:t>4️⃣ MANAGE EPICS &amp; STORIES: Break down requirements</a:t>
+            </a:r>
+            <a:br/>
+            <a:r>
+              <a:t>  → Assign resources to epics (determines Sprint Board teams)</a:t>
+            </a:r>
+            <a:br/>
+            <a:br/>
+            <a:r>
+              <a:t>5️⃣ GOVERNANCE CHECKLIST: ✅ Governance</a:t>
+            </a:r>
+            <a:br/>
+            <a:r>
+              <a:t>  → Generate Items or edit items individually</a:t>
+            </a:r>
+            <a:br/>
+            <a:br/>
+            <a:r>
+              <a:t>6️⃣ CREATE A RELEASE: 🚀 Releases → + New Release</a:t>
+            </a:r>
+            <a:br/>
+            <a:r>
+              <a:t>  → Register stories, sign off when ready</a:t>
+            </a:r>
+            <a:br/>
+            <a:br/>
+            <a:r>
+              <a:t>7️⃣ VIEW SPRINTS: 📋 Sprint Board for Team×Product grid</a:t>
+            </a:r>
+            <a:br/>
+            <a:r>
+              <a:t>  → Toggle 'Active only' as needed</a:t>
+            </a:r>
+            <a:br/>
+            <a:br/>
+            <a:r>
+              <a:t>8️⃣ CHECK PORTFOLIO: 📈 Portfolio for holistic VS view</a:t>
+            </a:r>
+            <a:br/>
+            <a:br/>
+            <a:r>
+              <a:t>9️⃣ LOCK PROJECT: 📁 Projects → 🔒 Lock button</a:t>
+            </a:r>
+            <a:br/>
+            <a:r>
+              <a:t>  → Admin/VSPMO/VSO only</a:t>
+            </a:r>
+            <a:br/>
+            <a:br/>
+            <a:r>
+              <a:t>🔟 UNLINK REQUIREMENT: 📋 Requirements → 📦 Backlog</a:t>
+            </a:r>
+            <a:br/>
+            <a:r>
+              <a:t>  → Moves item back to backlog pool</a:t>
+            </a:r>
+            <a:br/>
+            <a:br/>
+            <a:r>
+              <a:t>👤 SWITCH ROLE: Use role dropdown in header (DEV mode)</a:t>
+            </a:r>
+            <a:br/>
+            <a:r>
+              <a:t>🔄 RESET DATA: Click 🔄 Reset in header to clear all seed data</a:t>
+            </a:r>
+          </a:p>
+        </p:txBody>
+      </p:sp>
+      <p:sp>
+        <p:nvSpPr>
+          <p:cNvPr id="5" name="TextBox 4"/>
+          <p:cNvSpPr txBox="1"/>
+          <p:nvPr/>
+        </p:nvSpPr>
+        <p:spPr>
+          <a:xfrm>
+            <a:off x="11155680" y="777240"/>
+            <a:ext cx="731520" cy="274320"/>
+          </a:xfrm>
+          <a:prstGeom prst="rect">
+            <a:avLst/>
+          </a:prstGeom>
+          <a:noFill/>
+        </p:spPr>
+        <p:txBody>
+          <a:bodyPr wrap="none">
+            <a:spAutoFit/>
+          </a:bodyPr>
+          <a:lstStyle/>
+          <a:p>
+            <a:pPr algn="r">
+              <a:defRPr sz="1000">
+                <a:solidFill>
+                  <a:srgbClr val="C7D2FE"/>
+                </a:solidFill>
+              </a:defRPr>
+            </a:pPr>
+            <a:r>
+              <a:t>33/34</a:t>
+            </a:r>
+          </a:p>
+        </p:txBody>
+      </p:sp>
+      <p:sp>
+        <p:nvSpPr>
+          <p:cNvPr id="6" name="TextBox 5"/>
+          <p:cNvSpPr txBox="1"/>
+          <p:nvPr/>
+        </p:nvSpPr>
+        <p:spPr>
+          <a:xfrm>
+            <a:off x="457200" y="6446520"/>
+            <a:ext cx="11247120" cy="274320"/>
+          </a:xfrm>
+          <a:prstGeom prst="rect">
+            <a:avLst/>
+          </a:prstGeom>
+          <a:noFill/>
+        </p:spPr>
+        <p:txBody>
+          <a:bodyPr wrap="none">
+            <a:spAutoFit/>
+          </a:bodyPr>
+          <a:lstStyle/>
+          <a:p>
+            <a:pPr algn="ctr">
+              <a:defRPr sz="800">
+                <a:solidFill>
+                  <a:srgbClr val="64748B"/>
+                </a:solidFill>
+              </a:defRPr>
+            </a:pPr>
+            <a:r>
+              <a:t>Project Management Tool — Training Guide</a:t>
+            </a:r>
+          </a:p>
+        </p:txBody>
+      </p:sp>
+    </p:spTree>
+  </p:cSld>
+  <p:clrMapOvr>
+    <a:masterClrMapping/>
+  </p:clrMapOvr>
+</p:sld>
+</file>
+
+<file path=ppt/slides/slide34.xml><?xml version="1.0" encoding="utf-8"?>
+<p:sld xmlns:a="http://schemas.openxmlformats.org/drawingml/2006/main" xmlns:p="http://schemas.openxmlformats.org/presentationml/2006/main" xmlns:r="http://schemas.openxmlformats.org/officeDocument/2006/relationships">
+  <p:cSld>
+    <p:bg>
+      <p:bgPr>
+        <a:solidFill>
+          <a:srgbClr val="FFFFFF"/>
+        </a:solidFill>
+        <a:effectLst/>
+      </p:bgPr>
+    </p:bg>
+    <p:spTree>
+      <p:nvGrpSpPr>
+        <p:cNvPr id="1" name=""/>
+        <p:cNvGrpSpPr/>
+        <p:nvPr/>
+      </p:nvGrpSpPr>
+      <p:grpSpPr/>
+      <p:sp>
+        <p:nvSpPr>
+          <p:cNvPr id="2" name="Rectangle 1"/>
+          <p:cNvSpPr/>
+          <p:nvPr/>
+        </p:nvSpPr>
+        <p:spPr>
+          <a:xfrm>
+            <a:off x="0" y="0"/>
+            <a:ext cx="12191695" cy="1097280"/>
+          </a:xfrm>
+          <a:prstGeom prst="rect">
+            <a:avLst/>
+          </a:prstGeom>
+          <a:solidFill>
+            <a:srgbClr val="6366F1"/>
+          </a:solidFill>
+          <a:ln>
+            <a:noFill/>
+          </a:ln>
+        </p:spPr>
+        <p:style>
+          <a:lnRef idx="1">
+            <a:schemeClr val="accent1"/>
+          </a:lnRef>
+          <a:fillRef idx="3">
+            <a:schemeClr val="accent1"/>
+          </a:fillRef>
+          <a:effectRef idx="2">
+            <a:schemeClr val="accent1"/>
+          </a:effectRef>
+          <a:fontRef idx="minor">
+            <a:schemeClr val="lt1"/>
+          </a:fontRef>
+        </p:style>
+        <p:txBody>
+          <a:bodyPr rtlCol="0" anchor="ctr"/>
+          <a:lstStyle/>
+          <a:p>
+            <a:pPr algn="ctr"/>
+          </a:p>
+        </p:txBody>
+      </p:sp>
+      <p:sp>
+        <p:nvSpPr>
+          <p:cNvPr id="3" name="TextBox 2"/>
+          <p:cNvSpPr txBox="1"/>
+          <p:nvPr/>
+        </p:nvSpPr>
+        <p:spPr>
+          <a:xfrm>
+            <a:off x="731520" y="137160"/>
+            <a:ext cx="10515600" cy="594360"/>
+          </a:xfrm>
+          <a:prstGeom prst="rect">
+            <a:avLst/>
+          </a:prstGeom>
+          <a:noFill/>
+        </p:spPr>
+        <p:txBody>
+          <a:bodyPr wrap="none">
+            <a:spAutoFit/>
+          </a:bodyPr>
+          <a:lstStyle/>
+          <a:p>
+            <a:pPr algn="l">
+              <a:defRPr sz="2800" b="1">
+                <a:solidFill>
+                  <a:srgbClr val="FFFFFF"/>
+                </a:solidFill>
+              </a:defRPr>
+            </a:pPr>
+            <a:r>
               <a:t>Q&amp;A</a:t>
             </a:r>
           </a:p>
@@ -11023,7 +12978,7 @@
               </a:defRPr>
             </a:pPr>
             <a:r>
-              <a:t>33/33</a:t>
+              <a:t>34/34</a:t>
             </a:r>
           </a:p>
         </p:txBody>
@@ -11328,7 +13283,7 @@
               </a:defRPr>
             </a:pPr>
             <a:r>
-              <a:t>4/33</a:t>
+              <a:t>4/34</a:t>
             </a:r>
           </a:p>
         </p:txBody>
@@ -11601,7 +13556,7 @@
               </a:defRPr>
             </a:pPr>
             <a:r>
-              <a:t>5/33</a:t>
+              <a:t>5/34</a:t>
             </a:r>
           </a:p>
         </p:txBody>
@@ -11915,7 +13870,7 @@
               </a:defRPr>
             </a:pPr>
             <a:r>
-              <a:t>6/33</a:t>
+              <a:t>6/34</a:t>
             </a:r>
           </a:p>
         </p:txBody>
@@ -12221,7 +14176,7 @@
               </a:defRPr>
             </a:pPr>
             <a:r>
-              <a:t>7/33</a:t>
+              <a:t>7/34</a:t>
             </a:r>
           </a:p>
         </p:txBody>
@@ -12539,7 +14494,7 @@
               </a:defRPr>
             </a:pPr>
             <a:r>
-              <a:t>8/33</a:t>
+              <a:t>8/34</a:t>
             </a:r>
           </a:p>
         </p:txBody>
@@ -12849,7 +14804,7 @@
               </a:defRPr>
             </a:pPr>
             <a:r>
-              <a:t>9/33</a:t>
+              <a:t>9/34</a:t>
             </a:r>
           </a:p>
         </p:txBody>

</xml_diff>